<commit_message>
Update UML sequence diagram
</commit_message>
<xml_diff>
--- a/docs/diagrams/CategorySequenceDiagram.pptx
+++ b/docs/diagrams/CategorySequenceDiagram.pptx
@@ -7,6 +7,8 @@
   <p:sldIdLst>
     <p:sldId id="256" r:id="rId2"/>
     <p:sldId id="257" r:id="rId3"/>
+    <p:sldId id="258" r:id="rId4"/>
+    <p:sldId id="259" r:id="rId5"/>
   </p:sldIdLst>
   <p:sldSz cx="12192000" cy="6858000"/>
   <p:notesSz cx="6858000" cy="9144000"/>
@@ -105,6 +107,11 @@
       </a:defRPr>
     </a:lvl9pPr>
   </p:defaultTextStyle>
+  <p:extLst>
+    <p:ext uri="{EFAFB233-063F-42B5-8137-9DF3F51BA10A}">
+      <p15:sldGuideLst xmlns:p15="http://schemas.microsoft.com/office/powerpoint/2012/main"/>
+    </p:ext>
+  </p:extLst>
 </p:presentation>
 </file>
 
@@ -257,7 +264,7 @@
           <a:p>
             <a:fld id="{2F573F83-56BC-4405-BEB7-B720E0616CA9}" type="datetimeFigureOut">
               <a:rPr lang="en-SG" smtClean="0"/>
-              <a:t>21/10/2026</a:t>
+              <a:t>22/10/2026</a:t>
             </a:fld>
             <a:endParaRPr lang="en-SG"/>
           </a:p>
@@ -457,7 +464,7 @@
           <a:p>
             <a:fld id="{2F573F83-56BC-4405-BEB7-B720E0616CA9}" type="datetimeFigureOut">
               <a:rPr lang="en-SG" smtClean="0"/>
-              <a:t>21/10/2026</a:t>
+              <a:t>22/10/2026</a:t>
             </a:fld>
             <a:endParaRPr lang="en-SG"/>
           </a:p>
@@ -667,7 +674,7 @@
           <a:p>
             <a:fld id="{2F573F83-56BC-4405-BEB7-B720E0616CA9}" type="datetimeFigureOut">
               <a:rPr lang="en-SG" smtClean="0"/>
-              <a:t>21/10/2026</a:t>
+              <a:t>22/10/2026</a:t>
             </a:fld>
             <a:endParaRPr lang="en-SG"/>
           </a:p>
@@ -867,7 +874,7 @@
           <a:p>
             <a:fld id="{2F573F83-56BC-4405-BEB7-B720E0616CA9}" type="datetimeFigureOut">
               <a:rPr lang="en-SG" smtClean="0"/>
-              <a:t>21/10/2026</a:t>
+              <a:t>22/10/2026</a:t>
             </a:fld>
             <a:endParaRPr lang="en-SG"/>
           </a:p>
@@ -1143,7 +1150,7 @@
           <a:p>
             <a:fld id="{2F573F83-56BC-4405-BEB7-B720E0616CA9}" type="datetimeFigureOut">
               <a:rPr lang="en-SG" smtClean="0"/>
-              <a:t>21/10/2026</a:t>
+              <a:t>22/10/2026</a:t>
             </a:fld>
             <a:endParaRPr lang="en-SG"/>
           </a:p>
@@ -1411,7 +1418,7 @@
           <a:p>
             <a:fld id="{2F573F83-56BC-4405-BEB7-B720E0616CA9}" type="datetimeFigureOut">
               <a:rPr lang="en-SG" smtClean="0"/>
-              <a:t>21/10/2026</a:t>
+              <a:t>22/10/2026</a:t>
             </a:fld>
             <a:endParaRPr lang="en-SG"/>
           </a:p>
@@ -1826,7 +1833,7 @@
           <a:p>
             <a:fld id="{2F573F83-56BC-4405-BEB7-B720E0616CA9}" type="datetimeFigureOut">
               <a:rPr lang="en-SG" smtClean="0"/>
-              <a:t>21/10/2026</a:t>
+              <a:t>22/10/2026</a:t>
             </a:fld>
             <a:endParaRPr lang="en-SG"/>
           </a:p>
@@ -1968,7 +1975,7 @@
           <a:p>
             <a:fld id="{2F573F83-56BC-4405-BEB7-B720E0616CA9}" type="datetimeFigureOut">
               <a:rPr lang="en-SG" smtClean="0"/>
-              <a:t>21/10/2026</a:t>
+              <a:t>22/10/2026</a:t>
             </a:fld>
             <a:endParaRPr lang="en-SG"/>
           </a:p>
@@ -2081,7 +2088,7 @@
           <a:p>
             <a:fld id="{2F573F83-56BC-4405-BEB7-B720E0616CA9}" type="datetimeFigureOut">
               <a:rPr lang="en-SG" smtClean="0"/>
-              <a:t>21/10/2026</a:t>
+              <a:t>22/10/2026</a:t>
             </a:fld>
             <a:endParaRPr lang="en-SG"/>
           </a:p>
@@ -2394,7 +2401,7 @@
           <a:p>
             <a:fld id="{2F573F83-56BC-4405-BEB7-B720E0616CA9}" type="datetimeFigureOut">
               <a:rPr lang="en-SG" smtClean="0"/>
-              <a:t>21/10/2026</a:t>
+              <a:t>22/10/2026</a:t>
             </a:fld>
             <a:endParaRPr lang="en-SG"/>
           </a:p>
@@ -2683,7 +2690,7 @@
           <a:p>
             <a:fld id="{2F573F83-56BC-4405-BEB7-B720E0616CA9}" type="datetimeFigureOut">
               <a:rPr lang="en-SG" smtClean="0"/>
-              <a:t>21/10/2026</a:t>
+              <a:t>22/10/2026</a:t>
             </a:fld>
             <a:endParaRPr lang="en-SG"/>
           </a:p>
@@ -2926,7 +2933,7 @@
           <a:p>
             <a:fld id="{2F573F83-56BC-4405-BEB7-B720E0616CA9}" type="datetimeFigureOut">
               <a:rPr lang="en-SG" smtClean="0"/>
-              <a:t>21/10/2026</a:t>
+              <a:t>22/10/2026</a:t>
             </a:fld>
             <a:endParaRPr lang="en-SG"/>
           </a:p>
@@ -4614,8 +4621,8 @@
         </p:nvSpPr>
         <p:spPr>
           <a:xfrm>
-            <a:off x="4173620" y="5481734"/>
-            <a:ext cx="1882247" cy="369332"/>
+            <a:off x="4464360" y="5448422"/>
+            <a:ext cx="755400" cy="369332"/>
           </a:xfrm>
           <a:prstGeom prst="rect">
             <a:avLst/>
@@ -4630,7 +4637,7 @@
           <a:p>
             <a:r>
               <a:rPr lang="en-SG" dirty="0"/>
-              <a:t>CommandResult</a:t>
+              <a:t>result</a:t>
             </a:r>
           </a:p>
         </p:txBody>
@@ -5547,6 +5554,2614 @@
     <p:extLst>
       <p:ext uri="{BB962C8B-B14F-4D97-AF65-F5344CB8AC3E}">
         <p14:creationId xmlns:p14="http://schemas.microsoft.com/office/powerpoint/2010/main" val="2524151205"/>
+      </p:ext>
+    </p:extLst>
+  </p:cSld>
+  <p:clrMapOvr>
+    <a:masterClrMapping/>
+  </p:clrMapOvr>
+</p:sld>
+</file>
+
+<file path=ppt/slides/slide3.xml><?xml version="1.0" encoding="utf-8"?>
+<p:sld xmlns:a="http://schemas.openxmlformats.org/drawingml/2006/main" xmlns:r="http://schemas.openxmlformats.org/officeDocument/2006/relationships" xmlns:p="http://schemas.openxmlformats.org/presentationml/2006/main">
+  <p:cSld>
+    <p:spTree>
+      <p:nvGrpSpPr>
+        <p:cNvPr id="1" name=""/>
+        <p:cNvGrpSpPr/>
+        <p:nvPr/>
+      </p:nvGrpSpPr>
+      <p:grpSpPr>
+        <a:xfrm>
+          <a:off x="0" y="0"/>
+          <a:ext cx="0" cy="0"/>
+          <a:chOff x="0" y="0"/>
+          <a:chExt cx="0" cy="0"/>
+        </a:xfrm>
+      </p:grpSpPr>
+      <p:sp>
+        <p:nvSpPr>
+          <p:cNvPr id="6" name="Rectangle 5">
+            <a:extLst>
+              <a:ext uri="{FF2B5EF4-FFF2-40B4-BE49-F238E27FC236}">
+                <a16:creationId xmlns:a16="http://schemas.microsoft.com/office/drawing/2014/main" id="{501833A9-CD08-AA67-4E78-601CA60FF70F}"/>
+              </a:ext>
+            </a:extLst>
+          </p:cNvPr>
+          <p:cNvSpPr/>
+          <p:nvPr/>
+        </p:nvSpPr>
+        <p:spPr>
+          <a:xfrm>
+            <a:off x="1362141" y="96486"/>
+            <a:ext cx="7847717" cy="6590817"/>
+          </a:xfrm>
+          <a:prstGeom prst="rect">
+            <a:avLst/>
+          </a:prstGeom>
+          <a:solidFill>
+            <a:schemeClr val="tx2">
+              <a:lumMod val="25000"/>
+              <a:lumOff val="75000"/>
+            </a:schemeClr>
+          </a:solidFill>
+        </p:spPr>
+        <p:style>
+          <a:lnRef idx="2">
+            <a:schemeClr val="accent1">
+              <a:shade val="15000"/>
+            </a:schemeClr>
+          </a:lnRef>
+          <a:fillRef idx="1">
+            <a:schemeClr val="accent1"/>
+          </a:fillRef>
+          <a:effectRef idx="0">
+            <a:schemeClr val="accent1"/>
+          </a:effectRef>
+          <a:fontRef idx="minor">
+            <a:schemeClr val="lt1"/>
+          </a:fontRef>
+        </p:style>
+        <p:txBody>
+          <a:bodyPr rtlCol="0" anchor="ctr"/>
+          <a:lstStyle/>
+          <a:p>
+            <a:pPr algn="ctr"/>
+            <a:endParaRPr lang="en-SG" dirty="0"/>
+          </a:p>
+        </p:txBody>
+      </p:sp>
+      <p:cxnSp>
+        <p:nvCxnSpPr>
+          <p:cNvPr id="7" name="Straight Connector 6">
+            <a:extLst>
+              <a:ext uri="{FF2B5EF4-FFF2-40B4-BE49-F238E27FC236}">
+                <a16:creationId xmlns:a16="http://schemas.microsoft.com/office/drawing/2014/main" id="{336FE783-4BC5-D3DA-E9EF-81A4A8D3BF82}"/>
+              </a:ext>
+            </a:extLst>
+          </p:cNvPr>
+          <p:cNvCxnSpPr>
+            <a:cxnSpLocks/>
+          </p:cNvCxnSpPr>
+          <p:nvPr/>
+        </p:nvCxnSpPr>
+        <p:spPr>
+          <a:xfrm>
+            <a:off x="7082762" y="2227613"/>
+            <a:ext cx="40640" cy="4286992"/>
+          </a:xfrm>
+          <a:prstGeom prst="line">
+            <a:avLst/>
+          </a:prstGeom>
+          <a:ln w="19050" cap="flat" cmpd="sng" algn="ctr">
+            <a:solidFill>
+              <a:schemeClr val="dk1"/>
+            </a:solidFill>
+            <a:prstDash val="dash"/>
+            <a:round/>
+            <a:headEnd type="none" w="med" len="med"/>
+            <a:tailEnd type="none" w="med" len="med"/>
+          </a:ln>
+        </p:spPr>
+        <p:style>
+          <a:lnRef idx="0">
+            <a:scrgbClr r="0" g="0" b="0"/>
+          </a:lnRef>
+          <a:fillRef idx="0">
+            <a:scrgbClr r="0" g="0" b="0"/>
+          </a:fillRef>
+          <a:effectRef idx="0">
+            <a:scrgbClr r="0" g="0" b="0"/>
+          </a:effectRef>
+          <a:fontRef idx="minor">
+            <a:schemeClr val="tx1"/>
+          </a:fontRef>
+        </p:style>
+      </p:cxnSp>
+      <p:sp>
+        <p:nvSpPr>
+          <p:cNvPr id="8" name="Rectangle 7">
+            <a:extLst>
+              <a:ext uri="{FF2B5EF4-FFF2-40B4-BE49-F238E27FC236}">
+                <a16:creationId xmlns:a16="http://schemas.microsoft.com/office/drawing/2014/main" id="{9238C020-CAEE-4725-57EE-1705DA218EEB}"/>
+              </a:ext>
+            </a:extLst>
+          </p:cNvPr>
+          <p:cNvSpPr/>
+          <p:nvPr/>
+        </p:nvSpPr>
+        <p:spPr>
+          <a:xfrm>
+            <a:off x="9303435" y="130627"/>
+            <a:ext cx="1735775" cy="6568254"/>
+          </a:xfrm>
+          <a:prstGeom prst="rect">
+            <a:avLst/>
+          </a:prstGeom>
+          <a:solidFill>
+            <a:srgbClr val="FF6699"/>
+          </a:solidFill>
+        </p:spPr>
+        <p:style>
+          <a:lnRef idx="2">
+            <a:schemeClr val="accent1">
+              <a:shade val="15000"/>
+            </a:schemeClr>
+          </a:lnRef>
+          <a:fillRef idx="1">
+            <a:schemeClr val="accent1"/>
+          </a:fillRef>
+          <a:effectRef idx="0">
+            <a:schemeClr val="accent1"/>
+          </a:effectRef>
+          <a:fontRef idx="minor">
+            <a:schemeClr val="lt1"/>
+          </a:fontRef>
+        </p:style>
+        <p:txBody>
+          <a:bodyPr rtlCol="0" anchor="ctr"/>
+          <a:lstStyle/>
+          <a:p>
+            <a:pPr algn="ctr"/>
+            <a:endParaRPr lang="en-SG" dirty="0"/>
+          </a:p>
+        </p:txBody>
+      </p:sp>
+      <p:sp>
+        <p:nvSpPr>
+          <p:cNvPr id="9" name="TextBox 8">
+            <a:extLst>
+              <a:ext uri="{FF2B5EF4-FFF2-40B4-BE49-F238E27FC236}">
+                <a16:creationId xmlns:a16="http://schemas.microsoft.com/office/drawing/2014/main" id="{65828BC1-ED16-E658-9C01-FA43D32876B6}"/>
+              </a:ext>
+            </a:extLst>
+          </p:cNvPr>
+          <p:cNvSpPr txBox="1"/>
+          <p:nvPr/>
+        </p:nvSpPr>
+        <p:spPr>
+          <a:xfrm>
+            <a:off x="9768807" y="159119"/>
+            <a:ext cx="838691" cy="369332"/>
+          </a:xfrm>
+          <a:prstGeom prst="rect">
+            <a:avLst/>
+          </a:prstGeom>
+          <a:noFill/>
+        </p:spPr>
+        <p:txBody>
+          <a:bodyPr wrap="square" rtlCol="0">
+            <a:spAutoFit/>
+          </a:bodyPr>
+          <a:lstStyle/>
+          <a:p>
+            <a:r>
+              <a:rPr lang="en-SG" b="1" dirty="0">
+                <a:solidFill>
+                  <a:schemeClr val="bg1"/>
+                </a:solidFill>
+              </a:rPr>
+              <a:t>Model</a:t>
+            </a:r>
+          </a:p>
+        </p:txBody>
+      </p:sp>
+      <p:sp>
+        <p:nvSpPr>
+          <p:cNvPr id="10" name="Rectangle: Rounded Corners 9">
+            <a:extLst>
+              <a:ext uri="{FF2B5EF4-FFF2-40B4-BE49-F238E27FC236}">
+                <a16:creationId xmlns:a16="http://schemas.microsoft.com/office/drawing/2014/main" id="{4EE50A9E-913F-9FF8-31A3-D8C461041B1F}"/>
+              </a:ext>
+            </a:extLst>
+          </p:cNvPr>
+          <p:cNvSpPr/>
+          <p:nvPr/>
+        </p:nvSpPr>
+        <p:spPr>
+          <a:xfrm>
+            <a:off x="9734809" y="617191"/>
+            <a:ext cx="930435" cy="457200"/>
+          </a:xfrm>
+          <a:prstGeom prst="roundRect">
+            <a:avLst>
+              <a:gd name="adj" fmla="val 19265"/>
+            </a:avLst>
+          </a:prstGeom>
+          <a:solidFill>
+            <a:srgbClr val="C00000"/>
+          </a:solidFill>
+        </p:spPr>
+        <p:style>
+          <a:lnRef idx="2">
+            <a:schemeClr val="accent1">
+              <a:shade val="15000"/>
+            </a:schemeClr>
+          </a:lnRef>
+          <a:fillRef idx="1">
+            <a:schemeClr val="accent1"/>
+          </a:fillRef>
+          <a:effectRef idx="0">
+            <a:schemeClr val="accent1"/>
+          </a:effectRef>
+          <a:fontRef idx="minor">
+            <a:schemeClr val="lt1"/>
+          </a:fontRef>
+        </p:style>
+        <p:txBody>
+          <a:bodyPr rtlCol="0" anchor="ctr"/>
+          <a:lstStyle/>
+          <a:p>
+            <a:pPr algn="ctr"/>
+            <a:r>
+              <a:rPr lang="en-SG" dirty="0"/>
+              <a:t>:Model</a:t>
+            </a:r>
+          </a:p>
+        </p:txBody>
+      </p:sp>
+      <p:cxnSp>
+        <p:nvCxnSpPr>
+          <p:cNvPr id="11" name="Straight Connector 10">
+            <a:extLst>
+              <a:ext uri="{FF2B5EF4-FFF2-40B4-BE49-F238E27FC236}">
+                <a16:creationId xmlns:a16="http://schemas.microsoft.com/office/drawing/2014/main" id="{5376B538-C69A-A674-C1EF-60B10317A81E}"/>
+              </a:ext>
+            </a:extLst>
+          </p:cNvPr>
+          <p:cNvCxnSpPr>
+            <a:cxnSpLocks/>
+          </p:cNvCxnSpPr>
+          <p:nvPr/>
+        </p:nvCxnSpPr>
+        <p:spPr>
+          <a:xfrm>
+            <a:off x="10188152" y="1080654"/>
+            <a:ext cx="0" cy="5777346"/>
+          </a:xfrm>
+          <a:prstGeom prst="line">
+            <a:avLst/>
+          </a:prstGeom>
+          <a:ln w="19050" cap="flat" cmpd="sng" algn="ctr">
+            <a:solidFill>
+              <a:schemeClr val="dk1"/>
+            </a:solidFill>
+            <a:prstDash val="dash"/>
+            <a:round/>
+            <a:headEnd type="none" w="med" len="med"/>
+            <a:tailEnd type="none" w="med" len="med"/>
+          </a:ln>
+        </p:spPr>
+        <p:style>
+          <a:lnRef idx="0">
+            <a:scrgbClr r="0" g="0" b="0"/>
+          </a:lnRef>
+          <a:fillRef idx="0">
+            <a:scrgbClr r="0" g="0" b="0"/>
+          </a:fillRef>
+          <a:effectRef idx="0">
+            <a:scrgbClr r="0" g="0" b="0"/>
+          </a:effectRef>
+          <a:fontRef idx="minor">
+            <a:schemeClr val="tx1"/>
+          </a:fontRef>
+        </p:style>
+      </p:cxnSp>
+      <p:sp>
+        <p:nvSpPr>
+          <p:cNvPr id="12" name="Rectangle 11">
+            <a:extLst>
+              <a:ext uri="{FF2B5EF4-FFF2-40B4-BE49-F238E27FC236}">
+                <a16:creationId xmlns:a16="http://schemas.microsoft.com/office/drawing/2014/main" id="{0169DE9E-2A3D-C43A-5A9F-85757190616B}"/>
+              </a:ext>
+            </a:extLst>
+          </p:cNvPr>
+          <p:cNvSpPr/>
+          <p:nvPr/>
+        </p:nvSpPr>
+        <p:spPr>
+          <a:xfrm>
+            <a:off x="6982805" y="2085109"/>
+            <a:ext cx="213754" cy="415636"/>
+          </a:xfrm>
+          <a:prstGeom prst="rect">
+            <a:avLst/>
+          </a:prstGeom>
+          <a:solidFill>
+            <a:schemeClr val="bg1"/>
+          </a:solidFill>
+        </p:spPr>
+        <p:style>
+          <a:lnRef idx="2">
+            <a:schemeClr val="accent1">
+              <a:shade val="15000"/>
+            </a:schemeClr>
+          </a:lnRef>
+          <a:fillRef idx="1">
+            <a:schemeClr val="accent1"/>
+          </a:fillRef>
+          <a:effectRef idx="0">
+            <a:schemeClr val="accent1"/>
+          </a:effectRef>
+          <a:fontRef idx="minor">
+            <a:schemeClr val="lt1"/>
+          </a:fontRef>
+        </p:style>
+        <p:txBody>
+          <a:bodyPr rtlCol="0" anchor="ctr"/>
+          <a:lstStyle/>
+          <a:p>
+            <a:pPr algn="ctr"/>
+            <a:endParaRPr lang="en-SG"/>
+          </a:p>
+        </p:txBody>
+      </p:sp>
+      <p:sp>
+        <p:nvSpPr>
+          <p:cNvPr id="13" name="Rectangle: Rounded Corners 12">
+            <a:extLst>
+              <a:ext uri="{FF2B5EF4-FFF2-40B4-BE49-F238E27FC236}">
+                <a16:creationId xmlns:a16="http://schemas.microsoft.com/office/drawing/2014/main" id="{D1345E06-142A-40B5-66C7-54F8B12A794C}"/>
+              </a:ext>
+            </a:extLst>
+          </p:cNvPr>
+          <p:cNvSpPr/>
+          <p:nvPr/>
+        </p:nvSpPr>
+        <p:spPr>
+          <a:xfrm>
+            <a:off x="6027335" y="1681348"/>
+            <a:ext cx="2127196" cy="415636"/>
+          </a:xfrm>
+          <a:prstGeom prst="roundRect">
+            <a:avLst>
+              <a:gd name="adj" fmla="val 19265"/>
+            </a:avLst>
+          </a:prstGeom>
+          <a:solidFill>
+            <a:schemeClr val="tx2">
+              <a:lumMod val="75000"/>
+              <a:lumOff val="25000"/>
+            </a:schemeClr>
+          </a:solidFill>
+        </p:spPr>
+        <p:style>
+          <a:lnRef idx="2">
+            <a:schemeClr val="accent1">
+              <a:shade val="15000"/>
+            </a:schemeClr>
+          </a:lnRef>
+          <a:fillRef idx="1">
+            <a:schemeClr val="accent1"/>
+          </a:fillRef>
+          <a:effectRef idx="0">
+            <a:schemeClr val="accent1"/>
+          </a:effectRef>
+          <a:fontRef idx="minor">
+            <a:schemeClr val="lt1"/>
+          </a:fontRef>
+        </p:style>
+        <p:txBody>
+          <a:bodyPr rtlCol="0" anchor="ctr"/>
+          <a:lstStyle/>
+          <a:p>
+            <a:pPr algn="ctr"/>
+            <a:r>
+              <a:rPr lang="en-SG" sz="1500" dirty="0"/>
+              <a:t>cl:</a:t>
+            </a:r>
+            <a:r>
+              <a:rPr lang="en-SG" sz="1400" dirty="0"/>
+              <a:t>CategoriesCommand</a:t>
+            </a:r>
+          </a:p>
+        </p:txBody>
+      </p:sp>
+      <p:sp>
+        <p:nvSpPr>
+          <p:cNvPr id="14" name="TextBox 13">
+            <a:extLst>
+              <a:ext uri="{FF2B5EF4-FFF2-40B4-BE49-F238E27FC236}">
+                <a16:creationId xmlns:a16="http://schemas.microsoft.com/office/drawing/2014/main" id="{D5E194A5-0C51-24E6-9374-CBE15448F58B}"/>
+              </a:ext>
+            </a:extLst>
+          </p:cNvPr>
+          <p:cNvSpPr txBox="1"/>
+          <p:nvPr/>
+        </p:nvSpPr>
+        <p:spPr>
+          <a:xfrm>
+            <a:off x="4879081" y="211634"/>
+            <a:ext cx="838691" cy="369332"/>
+          </a:xfrm>
+          <a:prstGeom prst="rect">
+            <a:avLst/>
+          </a:prstGeom>
+          <a:noFill/>
+        </p:spPr>
+        <p:txBody>
+          <a:bodyPr wrap="square" rtlCol="0">
+            <a:spAutoFit/>
+          </a:bodyPr>
+          <a:lstStyle/>
+          <a:p>
+            <a:r>
+              <a:rPr lang="en-SG" b="1" dirty="0">
+                <a:solidFill>
+                  <a:schemeClr val="bg1"/>
+                </a:solidFill>
+              </a:rPr>
+              <a:t>Logic</a:t>
+            </a:r>
+          </a:p>
+        </p:txBody>
+      </p:sp>
+      <p:cxnSp>
+        <p:nvCxnSpPr>
+          <p:cNvPr id="15" name="Straight Connector 14">
+            <a:extLst>
+              <a:ext uri="{FF2B5EF4-FFF2-40B4-BE49-F238E27FC236}">
+                <a16:creationId xmlns:a16="http://schemas.microsoft.com/office/drawing/2014/main" id="{0704B5EE-0F6D-CE1B-D32E-0F4D36D26A48}"/>
+              </a:ext>
+            </a:extLst>
+          </p:cNvPr>
+          <p:cNvCxnSpPr>
+            <a:cxnSpLocks/>
+          </p:cNvCxnSpPr>
+          <p:nvPr/>
+        </p:nvCxnSpPr>
+        <p:spPr>
+          <a:xfrm>
+            <a:off x="3237123" y="1125343"/>
+            <a:ext cx="0" cy="5732657"/>
+          </a:xfrm>
+          <a:prstGeom prst="line">
+            <a:avLst/>
+          </a:prstGeom>
+          <a:ln w="19050" cap="flat" cmpd="sng" algn="ctr">
+            <a:solidFill>
+              <a:schemeClr val="dk1"/>
+            </a:solidFill>
+            <a:prstDash val="dash"/>
+            <a:round/>
+            <a:headEnd type="none" w="med" len="med"/>
+            <a:tailEnd type="none" w="med" len="med"/>
+          </a:ln>
+        </p:spPr>
+        <p:style>
+          <a:lnRef idx="0">
+            <a:scrgbClr r="0" g="0" b="0"/>
+          </a:lnRef>
+          <a:fillRef idx="0">
+            <a:scrgbClr r="0" g="0" b="0"/>
+          </a:fillRef>
+          <a:effectRef idx="0">
+            <a:scrgbClr r="0" g="0" b="0"/>
+          </a:effectRef>
+          <a:fontRef idx="minor">
+            <a:schemeClr val="tx1"/>
+          </a:fontRef>
+        </p:style>
+      </p:cxnSp>
+      <p:cxnSp>
+        <p:nvCxnSpPr>
+          <p:cNvPr id="16" name="Straight Arrow Connector 15">
+            <a:extLst>
+              <a:ext uri="{FF2B5EF4-FFF2-40B4-BE49-F238E27FC236}">
+                <a16:creationId xmlns:a16="http://schemas.microsoft.com/office/drawing/2014/main" id="{5472C34D-A358-3345-84B4-8A88341AAA77}"/>
+              </a:ext>
+            </a:extLst>
+          </p:cNvPr>
+          <p:cNvCxnSpPr>
+            <a:cxnSpLocks/>
+          </p:cNvCxnSpPr>
+          <p:nvPr/>
+        </p:nvCxnSpPr>
+        <p:spPr>
+          <a:xfrm>
+            <a:off x="0" y="1392472"/>
+            <a:ext cx="3148999" cy="0"/>
+          </a:xfrm>
+          <a:prstGeom prst="straightConnector1">
+            <a:avLst/>
+          </a:prstGeom>
+          <a:ln w="19050" cap="flat" cmpd="sng" algn="ctr">
+            <a:solidFill>
+              <a:schemeClr val="dk1"/>
+            </a:solidFill>
+            <a:prstDash val="solid"/>
+            <a:round/>
+            <a:headEnd type="none" w="med" len="med"/>
+            <a:tailEnd type="arrow" w="med" len="med"/>
+          </a:ln>
+        </p:spPr>
+        <p:style>
+          <a:lnRef idx="0">
+            <a:scrgbClr r="0" g="0" b="0"/>
+          </a:lnRef>
+          <a:fillRef idx="0">
+            <a:scrgbClr r="0" g="0" b="0"/>
+          </a:fillRef>
+          <a:effectRef idx="0">
+            <a:scrgbClr r="0" g="0" b="0"/>
+          </a:effectRef>
+          <a:fontRef idx="minor">
+            <a:schemeClr val="tx1"/>
+          </a:fontRef>
+        </p:style>
+      </p:cxnSp>
+      <p:sp>
+        <p:nvSpPr>
+          <p:cNvPr id="17" name="Rectangle: Rounded Corners 16">
+            <a:extLst>
+              <a:ext uri="{FF2B5EF4-FFF2-40B4-BE49-F238E27FC236}">
+                <a16:creationId xmlns:a16="http://schemas.microsoft.com/office/drawing/2014/main" id="{E55ABB8D-829A-80A4-C83F-EDB5CEF5F994}"/>
+              </a:ext>
+            </a:extLst>
+          </p:cNvPr>
+          <p:cNvSpPr/>
+          <p:nvPr/>
+        </p:nvSpPr>
+        <p:spPr>
+          <a:xfrm>
+            <a:off x="2495038" y="709707"/>
+            <a:ext cx="1597108" cy="415636"/>
+          </a:xfrm>
+          <a:prstGeom prst="roundRect">
+            <a:avLst>
+              <a:gd name="adj" fmla="val 19265"/>
+            </a:avLst>
+          </a:prstGeom>
+          <a:solidFill>
+            <a:schemeClr val="tx2">
+              <a:lumMod val="75000"/>
+              <a:lumOff val="25000"/>
+            </a:schemeClr>
+          </a:solidFill>
+        </p:spPr>
+        <p:style>
+          <a:lnRef idx="2">
+            <a:schemeClr val="accent1">
+              <a:shade val="15000"/>
+            </a:schemeClr>
+          </a:lnRef>
+          <a:fillRef idx="1">
+            <a:schemeClr val="accent1"/>
+          </a:fillRef>
+          <a:effectRef idx="0">
+            <a:schemeClr val="accent1"/>
+          </a:effectRef>
+          <a:fontRef idx="minor">
+            <a:schemeClr val="lt1"/>
+          </a:fontRef>
+        </p:style>
+        <p:txBody>
+          <a:bodyPr rtlCol="0" anchor="ctr"/>
+          <a:lstStyle/>
+          <a:p>
+            <a:pPr algn="ctr"/>
+            <a:r>
+              <a:rPr lang="en-SG" sz="1500" dirty="0"/>
+              <a:t>:LogicManager</a:t>
+            </a:r>
+          </a:p>
+        </p:txBody>
+      </p:sp>
+      <p:sp>
+        <p:nvSpPr>
+          <p:cNvPr id="18" name="TextBox 17">
+            <a:extLst>
+              <a:ext uri="{FF2B5EF4-FFF2-40B4-BE49-F238E27FC236}">
+                <a16:creationId xmlns:a16="http://schemas.microsoft.com/office/drawing/2014/main" id="{74BC8A44-9850-3977-E841-E9A253FCA58A}"/>
+              </a:ext>
+            </a:extLst>
+          </p:cNvPr>
+          <p:cNvSpPr txBox="1"/>
+          <p:nvPr/>
+        </p:nvSpPr>
+        <p:spPr>
+          <a:xfrm>
+            <a:off x="0" y="1018583"/>
+            <a:ext cx="2515625" cy="369332"/>
+          </a:xfrm>
+          <a:prstGeom prst="rect">
+            <a:avLst/>
+          </a:prstGeom>
+          <a:noFill/>
+        </p:spPr>
+        <p:txBody>
+          <a:bodyPr wrap="none" rtlCol="0">
+            <a:spAutoFit/>
+          </a:bodyPr>
+          <a:lstStyle/>
+          <a:p>
+            <a:r>
+              <a:rPr lang="en-SG" dirty="0"/>
+              <a:t>execute(commandText)</a:t>
+            </a:r>
+          </a:p>
+        </p:txBody>
+      </p:sp>
+      <p:sp>
+        <p:nvSpPr>
+          <p:cNvPr id="19" name="Rectangle 18">
+            <a:extLst>
+              <a:ext uri="{FF2B5EF4-FFF2-40B4-BE49-F238E27FC236}">
+                <a16:creationId xmlns:a16="http://schemas.microsoft.com/office/drawing/2014/main" id="{728839A2-5E7F-9656-FF3E-6025393ABCF7}"/>
+              </a:ext>
+            </a:extLst>
+          </p:cNvPr>
+          <p:cNvSpPr/>
+          <p:nvPr/>
+        </p:nvSpPr>
+        <p:spPr>
+          <a:xfrm>
+            <a:off x="3148999" y="1387914"/>
+            <a:ext cx="168663" cy="5039602"/>
+          </a:xfrm>
+          <a:prstGeom prst="rect">
+            <a:avLst/>
+          </a:prstGeom>
+          <a:solidFill>
+            <a:schemeClr val="bg1"/>
+          </a:solidFill>
+        </p:spPr>
+        <p:style>
+          <a:lnRef idx="2">
+            <a:schemeClr val="accent1">
+              <a:shade val="15000"/>
+            </a:schemeClr>
+          </a:lnRef>
+          <a:fillRef idx="1">
+            <a:schemeClr val="accent1"/>
+          </a:fillRef>
+          <a:effectRef idx="0">
+            <a:schemeClr val="accent1"/>
+          </a:effectRef>
+          <a:fontRef idx="minor">
+            <a:schemeClr val="lt1"/>
+          </a:fontRef>
+        </p:style>
+        <p:txBody>
+          <a:bodyPr rtlCol="0" anchor="ctr"/>
+          <a:lstStyle/>
+          <a:p>
+            <a:pPr algn="ctr"/>
+            <a:endParaRPr lang="en-SG"/>
+          </a:p>
+        </p:txBody>
+      </p:sp>
+      <p:cxnSp>
+        <p:nvCxnSpPr>
+          <p:cNvPr id="20" name="Straight Arrow Connector 19">
+            <a:extLst>
+              <a:ext uri="{FF2B5EF4-FFF2-40B4-BE49-F238E27FC236}">
+                <a16:creationId xmlns:a16="http://schemas.microsoft.com/office/drawing/2014/main" id="{C4975128-D726-06B9-EF2B-1B2366FD7FF7}"/>
+              </a:ext>
+            </a:extLst>
+          </p:cNvPr>
+          <p:cNvCxnSpPr>
+            <a:cxnSpLocks/>
+          </p:cNvCxnSpPr>
+          <p:nvPr/>
+        </p:nvCxnSpPr>
+        <p:spPr>
+          <a:xfrm flipV="1">
+            <a:off x="3325191" y="1579416"/>
+            <a:ext cx="2094517" cy="11874"/>
+          </a:xfrm>
+          <a:prstGeom prst="straightConnector1">
+            <a:avLst/>
+          </a:prstGeom>
+          <a:ln w="19050" cap="flat" cmpd="sng" algn="ctr">
+            <a:solidFill>
+              <a:schemeClr val="dk1"/>
+            </a:solidFill>
+            <a:prstDash val="solid"/>
+            <a:round/>
+            <a:headEnd type="none" w="med" len="med"/>
+            <a:tailEnd type="arrow" w="med" len="med"/>
+          </a:ln>
+        </p:spPr>
+        <p:style>
+          <a:lnRef idx="0">
+            <a:scrgbClr r="0" g="0" b="0"/>
+          </a:lnRef>
+          <a:fillRef idx="0">
+            <a:scrgbClr r="0" g="0" b="0"/>
+          </a:fillRef>
+          <a:effectRef idx="0">
+            <a:scrgbClr r="0" g="0" b="0"/>
+          </a:effectRef>
+          <a:fontRef idx="minor">
+            <a:schemeClr val="tx1"/>
+          </a:fontRef>
+        </p:style>
+      </p:cxnSp>
+      <p:sp>
+        <p:nvSpPr>
+          <p:cNvPr id="21" name="Rectangle: Rounded Corners 20">
+            <a:extLst>
+              <a:ext uri="{FF2B5EF4-FFF2-40B4-BE49-F238E27FC236}">
+                <a16:creationId xmlns:a16="http://schemas.microsoft.com/office/drawing/2014/main" id="{24F09B05-E235-AB57-C7BC-4304CD4F5718}"/>
+              </a:ext>
+            </a:extLst>
+          </p:cNvPr>
+          <p:cNvSpPr/>
+          <p:nvPr/>
+        </p:nvSpPr>
+        <p:spPr>
+          <a:xfrm>
+            <a:off x="4485693" y="709707"/>
+            <a:ext cx="2115442" cy="415636"/>
+          </a:xfrm>
+          <a:prstGeom prst="roundRect">
+            <a:avLst>
+              <a:gd name="adj" fmla="val 19265"/>
+            </a:avLst>
+          </a:prstGeom>
+          <a:solidFill>
+            <a:schemeClr val="tx2">
+              <a:lumMod val="75000"/>
+              <a:lumOff val="25000"/>
+            </a:schemeClr>
+          </a:solidFill>
+        </p:spPr>
+        <p:style>
+          <a:lnRef idx="2">
+            <a:schemeClr val="accent1">
+              <a:shade val="15000"/>
+            </a:schemeClr>
+          </a:lnRef>
+          <a:fillRef idx="1">
+            <a:schemeClr val="accent1"/>
+          </a:fillRef>
+          <a:effectRef idx="0">
+            <a:schemeClr val="accent1"/>
+          </a:effectRef>
+          <a:fontRef idx="minor">
+            <a:schemeClr val="lt1"/>
+          </a:fontRef>
+        </p:style>
+        <p:txBody>
+          <a:bodyPr rtlCol="0" anchor="ctr"/>
+          <a:lstStyle/>
+          <a:p>
+            <a:pPr algn="ctr"/>
+            <a:r>
+              <a:rPr lang="en-SG" sz="1500" dirty="0"/>
+              <a:t>:AddressBookParser</a:t>
+            </a:r>
+          </a:p>
+        </p:txBody>
+      </p:sp>
+      <p:cxnSp>
+        <p:nvCxnSpPr>
+          <p:cNvPr id="22" name="Straight Connector 21">
+            <a:extLst>
+              <a:ext uri="{FF2B5EF4-FFF2-40B4-BE49-F238E27FC236}">
+                <a16:creationId xmlns:a16="http://schemas.microsoft.com/office/drawing/2014/main" id="{814BE080-C4E2-F12C-0676-0B8C3ADDDB84}"/>
+              </a:ext>
+            </a:extLst>
+          </p:cNvPr>
+          <p:cNvCxnSpPr>
+            <a:cxnSpLocks/>
+          </p:cNvCxnSpPr>
+          <p:nvPr/>
+        </p:nvCxnSpPr>
+        <p:spPr>
+          <a:xfrm>
+            <a:off x="5543414" y="1163781"/>
+            <a:ext cx="0" cy="5694219"/>
+          </a:xfrm>
+          <a:prstGeom prst="line">
+            <a:avLst/>
+          </a:prstGeom>
+          <a:ln w="19050" cap="flat" cmpd="sng" algn="ctr">
+            <a:solidFill>
+              <a:schemeClr val="dk1"/>
+            </a:solidFill>
+            <a:prstDash val="dash"/>
+            <a:round/>
+            <a:headEnd type="none" w="med" len="med"/>
+            <a:tailEnd type="none" w="med" len="med"/>
+          </a:ln>
+        </p:spPr>
+        <p:style>
+          <a:lnRef idx="0">
+            <a:scrgbClr r="0" g="0" b="0"/>
+          </a:lnRef>
+          <a:fillRef idx="0">
+            <a:scrgbClr r="0" g="0" b="0"/>
+          </a:fillRef>
+          <a:effectRef idx="0">
+            <a:scrgbClr r="0" g="0" b="0"/>
+          </a:effectRef>
+          <a:fontRef idx="minor">
+            <a:schemeClr val="tx1"/>
+          </a:fontRef>
+        </p:style>
+      </p:cxnSp>
+      <p:sp>
+        <p:nvSpPr>
+          <p:cNvPr id="23" name="Rectangle 22">
+            <a:extLst>
+              <a:ext uri="{FF2B5EF4-FFF2-40B4-BE49-F238E27FC236}">
+                <a16:creationId xmlns:a16="http://schemas.microsoft.com/office/drawing/2014/main" id="{9FFB2F8B-BB81-C2E3-E844-125AC2E1F4B2}"/>
+              </a:ext>
+            </a:extLst>
+          </p:cNvPr>
+          <p:cNvSpPr/>
+          <p:nvPr/>
+        </p:nvSpPr>
+        <p:spPr>
+          <a:xfrm>
+            <a:off x="5436537" y="1579416"/>
+            <a:ext cx="211772" cy="1781297"/>
+          </a:xfrm>
+          <a:prstGeom prst="rect">
+            <a:avLst/>
+          </a:prstGeom>
+          <a:solidFill>
+            <a:schemeClr val="bg1"/>
+          </a:solidFill>
+        </p:spPr>
+        <p:style>
+          <a:lnRef idx="2">
+            <a:schemeClr val="accent1">
+              <a:shade val="15000"/>
+            </a:schemeClr>
+          </a:lnRef>
+          <a:fillRef idx="1">
+            <a:schemeClr val="accent1"/>
+          </a:fillRef>
+          <a:effectRef idx="0">
+            <a:schemeClr val="accent1"/>
+          </a:effectRef>
+          <a:fontRef idx="minor">
+            <a:schemeClr val="lt1"/>
+          </a:fontRef>
+        </p:style>
+        <p:txBody>
+          <a:bodyPr rtlCol="0" anchor="ctr"/>
+          <a:lstStyle/>
+          <a:p>
+            <a:pPr algn="ctr"/>
+            <a:endParaRPr lang="en-SG"/>
+          </a:p>
+        </p:txBody>
+      </p:sp>
+      <p:cxnSp>
+        <p:nvCxnSpPr>
+          <p:cNvPr id="24" name="Straight Arrow Connector 23">
+            <a:extLst>
+              <a:ext uri="{FF2B5EF4-FFF2-40B4-BE49-F238E27FC236}">
+                <a16:creationId xmlns:a16="http://schemas.microsoft.com/office/drawing/2014/main" id="{1765EB48-E35B-381B-9141-89FD1C7450B6}"/>
+              </a:ext>
+            </a:extLst>
+          </p:cNvPr>
+          <p:cNvCxnSpPr>
+            <a:cxnSpLocks/>
+          </p:cNvCxnSpPr>
+          <p:nvPr/>
+        </p:nvCxnSpPr>
+        <p:spPr>
+          <a:xfrm>
+            <a:off x="5648309" y="1831604"/>
+            <a:ext cx="379026" cy="0"/>
+          </a:xfrm>
+          <a:prstGeom prst="straightConnector1">
+            <a:avLst/>
+          </a:prstGeom>
+          <a:ln w="19050" cap="flat" cmpd="sng" algn="ctr">
+            <a:solidFill>
+              <a:schemeClr val="dk1"/>
+            </a:solidFill>
+            <a:prstDash val="solid"/>
+            <a:round/>
+            <a:headEnd type="none" w="med" len="med"/>
+            <a:tailEnd type="arrow" w="med" len="med"/>
+          </a:ln>
+        </p:spPr>
+        <p:style>
+          <a:lnRef idx="0">
+            <a:scrgbClr r="0" g="0" b="0"/>
+          </a:lnRef>
+          <a:fillRef idx="0">
+            <a:scrgbClr r="0" g="0" b="0"/>
+          </a:fillRef>
+          <a:effectRef idx="0">
+            <a:scrgbClr r="0" g="0" b="0"/>
+          </a:effectRef>
+          <a:fontRef idx="minor">
+            <a:schemeClr val="tx1"/>
+          </a:fontRef>
+        </p:style>
+      </p:cxnSp>
+      <p:cxnSp>
+        <p:nvCxnSpPr>
+          <p:cNvPr id="25" name="Straight Arrow Connector 24">
+            <a:extLst>
+              <a:ext uri="{FF2B5EF4-FFF2-40B4-BE49-F238E27FC236}">
+                <a16:creationId xmlns:a16="http://schemas.microsoft.com/office/drawing/2014/main" id="{05414516-95C2-3EE2-0F2E-256A8FF5226C}"/>
+              </a:ext>
+            </a:extLst>
+          </p:cNvPr>
+          <p:cNvCxnSpPr>
+            <a:cxnSpLocks/>
+            <a:stCxn id="12" idx="2"/>
+          </p:cNvCxnSpPr>
+          <p:nvPr/>
+        </p:nvCxnSpPr>
+        <p:spPr>
+          <a:xfrm flipH="1">
+            <a:off x="5681712" y="2500745"/>
+            <a:ext cx="1407970" cy="7878"/>
+          </a:xfrm>
+          <a:prstGeom prst="straightConnector1">
+            <a:avLst/>
+          </a:prstGeom>
+          <a:ln w="19050" cap="flat" cmpd="sng" algn="ctr">
+            <a:solidFill>
+              <a:schemeClr val="dk1"/>
+            </a:solidFill>
+            <a:prstDash val="dash"/>
+            <a:round/>
+            <a:headEnd type="none" w="med" len="med"/>
+            <a:tailEnd type="arrow" w="med" len="med"/>
+          </a:ln>
+        </p:spPr>
+        <p:style>
+          <a:lnRef idx="0">
+            <a:scrgbClr r="0" g="0" b="0"/>
+          </a:lnRef>
+          <a:fillRef idx="0">
+            <a:scrgbClr r="0" g="0" b="0"/>
+          </a:fillRef>
+          <a:effectRef idx="0">
+            <a:scrgbClr r="0" g="0" b="0"/>
+          </a:effectRef>
+          <a:fontRef idx="minor">
+            <a:schemeClr val="tx1"/>
+          </a:fontRef>
+        </p:style>
+      </p:cxnSp>
+      <p:cxnSp>
+        <p:nvCxnSpPr>
+          <p:cNvPr id="26" name="Straight Arrow Connector 25">
+            <a:extLst>
+              <a:ext uri="{FF2B5EF4-FFF2-40B4-BE49-F238E27FC236}">
+                <a16:creationId xmlns:a16="http://schemas.microsoft.com/office/drawing/2014/main" id="{881F9447-CE4D-AC2A-4370-9C79DCB167AB}"/>
+              </a:ext>
+            </a:extLst>
+          </p:cNvPr>
+          <p:cNvCxnSpPr>
+            <a:cxnSpLocks/>
+          </p:cNvCxnSpPr>
+          <p:nvPr/>
+        </p:nvCxnSpPr>
+        <p:spPr>
+          <a:xfrm flipH="1" flipV="1">
+            <a:off x="3375423" y="3334980"/>
+            <a:ext cx="2027711" cy="1979"/>
+          </a:xfrm>
+          <a:prstGeom prst="straightConnector1">
+            <a:avLst/>
+          </a:prstGeom>
+          <a:ln w="19050" cap="flat" cmpd="sng" algn="ctr">
+            <a:solidFill>
+              <a:schemeClr val="dk1"/>
+            </a:solidFill>
+            <a:prstDash val="dash"/>
+            <a:round/>
+            <a:headEnd type="none" w="med" len="med"/>
+            <a:tailEnd type="arrow" w="med" len="med"/>
+          </a:ln>
+        </p:spPr>
+        <p:style>
+          <a:lnRef idx="0">
+            <a:scrgbClr r="0" g="0" b="0"/>
+          </a:lnRef>
+          <a:fillRef idx="0">
+            <a:scrgbClr r="0" g="0" b="0"/>
+          </a:fillRef>
+          <a:effectRef idx="0">
+            <a:scrgbClr r="0" g="0" b="0"/>
+          </a:effectRef>
+          <a:fontRef idx="minor">
+            <a:schemeClr val="tx1"/>
+          </a:fontRef>
+        </p:style>
+      </p:cxnSp>
+      <p:sp>
+        <p:nvSpPr>
+          <p:cNvPr id="27" name="TextBox 26">
+            <a:extLst>
+              <a:ext uri="{FF2B5EF4-FFF2-40B4-BE49-F238E27FC236}">
+                <a16:creationId xmlns:a16="http://schemas.microsoft.com/office/drawing/2014/main" id="{4C9C2C8E-0066-BD7C-7ADF-2016ACBD16EE}"/>
+              </a:ext>
+            </a:extLst>
+          </p:cNvPr>
+          <p:cNvSpPr txBox="1"/>
+          <p:nvPr/>
+        </p:nvSpPr>
+        <p:spPr>
+          <a:xfrm>
+            <a:off x="4236031" y="2930022"/>
+            <a:ext cx="306494" cy="369332"/>
+          </a:xfrm>
+          <a:prstGeom prst="rect">
+            <a:avLst/>
+          </a:prstGeom>
+          <a:noFill/>
+        </p:spPr>
+        <p:txBody>
+          <a:bodyPr wrap="none" rtlCol="0">
+            <a:spAutoFit/>
+          </a:bodyPr>
+          <a:lstStyle/>
+          <a:p>
+            <a:r>
+              <a:rPr lang="en-SG" dirty="0"/>
+              <a:t>c</a:t>
+            </a:r>
+          </a:p>
+        </p:txBody>
+      </p:sp>
+      <p:sp>
+        <p:nvSpPr>
+          <p:cNvPr id="28" name="TextBox 27">
+            <a:extLst>
+              <a:ext uri="{FF2B5EF4-FFF2-40B4-BE49-F238E27FC236}">
+                <a16:creationId xmlns:a16="http://schemas.microsoft.com/office/drawing/2014/main" id="{C4C532E5-0365-1A34-10BA-F87E6DB96B05}"/>
+              </a:ext>
+            </a:extLst>
+          </p:cNvPr>
+          <p:cNvSpPr txBox="1"/>
+          <p:nvPr/>
+        </p:nvSpPr>
+        <p:spPr>
+          <a:xfrm>
+            <a:off x="3452060" y="1579416"/>
+            <a:ext cx="1839195" cy="646331"/>
+          </a:xfrm>
+          <a:prstGeom prst="rect">
+            <a:avLst/>
+          </a:prstGeom>
+          <a:noFill/>
+        </p:spPr>
+        <p:txBody>
+          <a:bodyPr wrap="square" rtlCol="0">
+            <a:spAutoFit/>
+          </a:bodyPr>
+          <a:lstStyle/>
+          <a:p>
+            <a:r>
+              <a:rPr lang="en-SG" dirty="0"/>
+              <a:t>parseCommand(commandText)</a:t>
+            </a:r>
+          </a:p>
+        </p:txBody>
+      </p:sp>
+      <p:cxnSp>
+        <p:nvCxnSpPr>
+          <p:cNvPr id="29" name="Straight Arrow Connector 28">
+            <a:extLst>
+              <a:ext uri="{FF2B5EF4-FFF2-40B4-BE49-F238E27FC236}">
+                <a16:creationId xmlns:a16="http://schemas.microsoft.com/office/drawing/2014/main" id="{B04111C9-870E-1559-1F95-C90244929077}"/>
+              </a:ext>
+            </a:extLst>
+          </p:cNvPr>
+          <p:cNvCxnSpPr>
+            <a:cxnSpLocks/>
+          </p:cNvCxnSpPr>
+          <p:nvPr/>
+        </p:nvCxnSpPr>
+        <p:spPr>
+          <a:xfrm>
+            <a:off x="3335598" y="3471553"/>
+            <a:ext cx="3606566" cy="0"/>
+          </a:xfrm>
+          <a:prstGeom prst="straightConnector1">
+            <a:avLst/>
+          </a:prstGeom>
+          <a:ln w="19050" cap="flat" cmpd="sng" algn="ctr">
+            <a:solidFill>
+              <a:schemeClr val="dk1"/>
+            </a:solidFill>
+            <a:prstDash val="solid"/>
+            <a:round/>
+            <a:headEnd type="none" w="med" len="med"/>
+            <a:tailEnd type="arrow" w="med" len="med"/>
+          </a:ln>
+        </p:spPr>
+        <p:style>
+          <a:lnRef idx="0">
+            <a:scrgbClr r="0" g="0" b="0"/>
+          </a:lnRef>
+          <a:fillRef idx="0">
+            <a:scrgbClr r="0" g="0" b="0"/>
+          </a:fillRef>
+          <a:effectRef idx="0">
+            <a:scrgbClr r="0" g="0" b="0"/>
+          </a:effectRef>
+          <a:fontRef idx="minor">
+            <a:schemeClr val="tx1"/>
+          </a:fontRef>
+        </p:style>
+      </p:cxnSp>
+      <p:sp>
+        <p:nvSpPr>
+          <p:cNvPr id="30" name="Rectangle 29">
+            <a:extLst>
+              <a:ext uri="{FF2B5EF4-FFF2-40B4-BE49-F238E27FC236}">
+                <a16:creationId xmlns:a16="http://schemas.microsoft.com/office/drawing/2014/main" id="{29183A44-C72F-0E00-51CF-9F5E7A6275D9}"/>
+              </a:ext>
+            </a:extLst>
+          </p:cNvPr>
+          <p:cNvSpPr/>
+          <p:nvPr/>
+        </p:nvSpPr>
+        <p:spPr>
+          <a:xfrm>
+            <a:off x="6975885" y="3471553"/>
+            <a:ext cx="213753" cy="2750467"/>
+          </a:xfrm>
+          <a:prstGeom prst="rect">
+            <a:avLst/>
+          </a:prstGeom>
+          <a:solidFill>
+            <a:schemeClr val="bg1"/>
+          </a:solidFill>
+        </p:spPr>
+        <p:style>
+          <a:lnRef idx="2">
+            <a:schemeClr val="accent1">
+              <a:shade val="15000"/>
+            </a:schemeClr>
+          </a:lnRef>
+          <a:fillRef idx="1">
+            <a:schemeClr val="accent1"/>
+          </a:fillRef>
+          <a:effectRef idx="0">
+            <a:schemeClr val="accent1"/>
+          </a:effectRef>
+          <a:fontRef idx="minor">
+            <a:schemeClr val="lt1"/>
+          </a:fontRef>
+        </p:style>
+        <p:txBody>
+          <a:bodyPr rtlCol="0" anchor="ctr"/>
+          <a:lstStyle/>
+          <a:p>
+            <a:pPr algn="ctr"/>
+            <a:endParaRPr lang="en-SG"/>
+          </a:p>
+        </p:txBody>
+      </p:sp>
+      <p:cxnSp>
+        <p:nvCxnSpPr>
+          <p:cNvPr id="31" name="Straight Arrow Connector 30">
+            <a:extLst>
+              <a:ext uri="{FF2B5EF4-FFF2-40B4-BE49-F238E27FC236}">
+                <a16:creationId xmlns:a16="http://schemas.microsoft.com/office/drawing/2014/main" id="{0574F6A7-94B3-C6F4-1744-83DC4F2B4C02}"/>
+              </a:ext>
+            </a:extLst>
+          </p:cNvPr>
+          <p:cNvCxnSpPr>
+            <a:cxnSpLocks/>
+          </p:cNvCxnSpPr>
+          <p:nvPr/>
+        </p:nvCxnSpPr>
+        <p:spPr>
+          <a:xfrm flipH="1">
+            <a:off x="3343133" y="6200838"/>
+            <a:ext cx="3640287" cy="0"/>
+          </a:xfrm>
+          <a:prstGeom prst="straightConnector1">
+            <a:avLst/>
+          </a:prstGeom>
+          <a:ln w="19050" cap="flat" cmpd="sng" algn="ctr">
+            <a:solidFill>
+              <a:schemeClr val="tx1"/>
+            </a:solidFill>
+            <a:prstDash val="dash"/>
+            <a:round/>
+            <a:headEnd type="none" w="med" len="med"/>
+            <a:tailEnd type="arrow" w="med" len="med"/>
+          </a:ln>
+        </p:spPr>
+        <p:style>
+          <a:lnRef idx="0">
+            <a:scrgbClr r="0" g="0" b="0"/>
+          </a:lnRef>
+          <a:fillRef idx="0">
+            <a:scrgbClr r="0" g="0" b="0"/>
+          </a:fillRef>
+          <a:effectRef idx="0">
+            <a:scrgbClr r="0" g="0" b="0"/>
+          </a:effectRef>
+          <a:fontRef idx="minor">
+            <a:schemeClr val="tx1"/>
+          </a:fontRef>
+        </p:style>
+      </p:cxnSp>
+      <p:sp>
+        <p:nvSpPr>
+          <p:cNvPr id="32" name="TextBox 31">
+            <a:extLst>
+              <a:ext uri="{FF2B5EF4-FFF2-40B4-BE49-F238E27FC236}">
+                <a16:creationId xmlns:a16="http://schemas.microsoft.com/office/drawing/2014/main" id="{BD58184B-E40A-B057-255A-EC2BCEA12C63}"/>
+              </a:ext>
+            </a:extLst>
+          </p:cNvPr>
+          <p:cNvSpPr txBox="1"/>
+          <p:nvPr/>
+        </p:nvSpPr>
+        <p:spPr>
+          <a:xfrm>
+            <a:off x="4074271" y="3553527"/>
+            <a:ext cx="1236172" cy="369332"/>
+          </a:xfrm>
+          <a:prstGeom prst="rect">
+            <a:avLst/>
+          </a:prstGeom>
+          <a:noFill/>
+        </p:spPr>
+        <p:txBody>
+          <a:bodyPr wrap="none" rtlCol="0">
+            <a:spAutoFit/>
+          </a:bodyPr>
+          <a:lstStyle/>
+          <a:p>
+            <a:r>
+              <a:rPr lang="en-SG" dirty="0"/>
+              <a:t>execute(c)</a:t>
+            </a:r>
+          </a:p>
+        </p:txBody>
+      </p:sp>
+      <p:sp>
+        <p:nvSpPr>
+          <p:cNvPr id="33" name="TextBox 32">
+            <a:extLst>
+              <a:ext uri="{FF2B5EF4-FFF2-40B4-BE49-F238E27FC236}">
+                <a16:creationId xmlns:a16="http://schemas.microsoft.com/office/drawing/2014/main" id="{DAB2C381-29AF-0C57-832D-1A57017AC516}"/>
+              </a:ext>
+            </a:extLst>
+          </p:cNvPr>
+          <p:cNvSpPr txBox="1"/>
+          <p:nvPr/>
+        </p:nvSpPr>
+        <p:spPr>
+          <a:xfrm>
+            <a:off x="4661935" y="5823628"/>
+            <a:ext cx="755400" cy="369332"/>
+          </a:xfrm>
+          <a:prstGeom prst="rect">
+            <a:avLst/>
+          </a:prstGeom>
+          <a:noFill/>
+        </p:spPr>
+        <p:txBody>
+          <a:bodyPr wrap="none" rtlCol="0">
+            <a:spAutoFit/>
+          </a:bodyPr>
+          <a:lstStyle/>
+          <a:p>
+            <a:r>
+              <a:rPr lang="en-SG" dirty="0"/>
+              <a:t>result</a:t>
+            </a:r>
+          </a:p>
+        </p:txBody>
+      </p:sp>
+      <p:cxnSp>
+        <p:nvCxnSpPr>
+          <p:cNvPr id="34" name="Straight Arrow Connector 33">
+            <a:extLst>
+              <a:ext uri="{FF2B5EF4-FFF2-40B4-BE49-F238E27FC236}">
+                <a16:creationId xmlns:a16="http://schemas.microsoft.com/office/drawing/2014/main" id="{5DA26CC6-157F-81F7-677A-B7A924AC375E}"/>
+              </a:ext>
+            </a:extLst>
+          </p:cNvPr>
+          <p:cNvCxnSpPr>
+            <a:cxnSpLocks/>
+          </p:cNvCxnSpPr>
+          <p:nvPr/>
+        </p:nvCxnSpPr>
+        <p:spPr>
+          <a:xfrm>
+            <a:off x="7189638" y="3863441"/>
+            <a:ext cx="2884529" cy="12081"/>
+          </a:xfrm>
+          <a:prstGeom prst="straightConnector1">
+            <a:avLst/>
+          </a:prstGeom>
+          <a:ln w="19050" cap="flat" cmpd="sng" algn="ctr">
+            <a:solidFill>
+              <a:schemeClr val="dk1"/>
+            </a:solidFill>
+            <a:prstDash val="solid"/>
+            <a:round/>
+            <a:headEnd type="none" w="med" len="med"/>
+            <a:tailEnd type="arrow" w="med" len="med"/>
+          </a:ln>
+        </p:spPr>
+        <p:style>
+          <a:lnRef idx="0">
+            <a:scrgbClr r="0" g="0" b="0"/>
+          </a:lnRef>
+          <a:fillRef idx="0">
+            <a:scrgbClr r="0" g="0" b="0"/>
+          </a:fillRef>
+          <a:effectRef idx="0">
+            <a:scrgbClr r="0" g="0" b="0"/>
+          </a:effectRef>
+          <a:fontRef idx="minor">
+            <a:schemeClr val="tx1"/>
+          </a:fontRef>
+        </p:style>
+      </p:cxnSp>
+      <p:sp>
+        <p:nvSpPr>
+          <p:cNvPr id="35" name="Rectangle 34">
+            <a:extLst>
+              <a:ext uri="{FF2B5EF4-FFF2-40B4-BE49-F238E27FC236}">
+                <a16:creationId xmlns:a16="http://schemas.microsoft.com/office/drawing/2014/main" id="{D09E45F3-358F-0804-CB7E-E903D4ACF160}"/>
+              </a:ext>
+            </a:extLst>
+          </p:cNvPr>
+          <p:cNvSpPr/>
+          <p:nvPr/>
+        </p:nvSpPr>
+        <p:spPr>
+          <a:xfrm>
+            <a:off x="10074168" y="3863441"/>
+            <a:ext cx="214820" cy="307778"/>
+          </a:xfrm>
+          <a:prstGeom prst="rect">
+            <a:avLst/>
+          </a:prstGeom>
+          <a:solidFill>
+            <a:schemeClr val="bg1"/>
+          </a:solidFill>
+        </p:spPr>
+        <p:style>
+          <a:lnRef idx="2">
+            <a:schemeClr val="accent1">
+              <a:shade val="15000"/>
+            </a:schemeClr>
+          </a:lnRef>
+          <a:fillRef idx="1">
+            <a:schemeClr val="accent1"/>
+          </a:fillRef>
+          <a:effectRef idx="0">
+            <a:schemeClr val="accent1"/>
+          </a:effectRef>
+          <a:fontRef idx="minor">
+            <a:schemeClr val="lt1"/>
+          </a:fontRef>
+        </p:style>
+        <p:txBody>
+          <a:bodyPr rtlCol="0" anchor="ctr"/>
+          <a:lstStyle/>
+          <a:p>
+            <a:pPr algn="ctr"/>
+            <a:endParaRPr lang="en-SG"/>
+          </a:p>
+        </p:txBody>
+      </p:sp>
+      <p:cxnSp>
+        <p:nvCxnSpPr>
+          <p:cNvPr id="36" name="Straight Arrow Connector 35">
+            <a:extLst>
+              <a:ext uri="{FF2B5EF4-FFF2-40B4-BE49-F238E27FC236}">
+                <a16:creationId xmlns:a16="http://schemas.microsoft.com/office/drawing/2014/main" id="{2DFC5531-081A-0F9B-8F74-CE67E743E920}"/>
+              </a:ext>
+            </a:extLst>
+          </p:cNvPr>
+          <p:cNvCxnSpPr>
+            <a:cxnSpLocks/>
+          </p:cNvCxnSpPr>
+          <p:nvPr/>
+        </p:nvCxnSpPr>
+        <p:spPr>
+          <a:xfrm flipH="1">
+            <a:off x="7223359" y="4163657"/>
+            <a:ext cx="2850808" cy="0"/>
+          </a:xfrm>
+          <a:prstGeom prst="straightConnector1">
+            <a:avLst/>
+          </a:prstGeom>
+          <a:ln w="19050" cap="flat" cmpd="sng" algn="ctr">
+            <a:solidFill>
+              <a:schemeClr val="dk1"/>
+            </a:solidFill>
+            <a:prstDash val="dash"/>
+            <a:round/>
+            <a:headEnd type="none" w="med" len="med"/>
+            <a:tailEnd type="arrow" w="med" len="med"/>
+          </a:ln>
+        </p:spPr>
+        <p:style>
+          <a:lnRef idx="0">
+            <a:scrgbClr r="0" g="0" b="0"/>
+          </a:lnRef>
+          <a:fillRef idx="0">
+            <a:scrgbClr r="0" g="0" b="0"/>
+          </a:fillRef>
+          <a:effectRef idx="0">
+            <a:scrgbClr r="0" g="0" b="0"/>
+          </a:effectRef>
+          <a:fontRef idx="minor">
+            <a:schemeClr val="tx1"/>
+          </a:fontRef>
+        </p:style>
+      </p:cxnSp>
+      <p:sp>
+        <p:nvSpPr>
+          <p:cNvPr id="37" name="TextBox 36">
+            <a:extLst>
+              <a:ext uri="{FF2B5EF4-FFF2-40B4-BE49-F238E27FC236}">
+                <a16:creationId xmlns:a16="http://schemas.microsoft.com/office/drawing/2014/main" id="{2DA33A6E-92AE-044F-DAFD-6BB7939DE817}"/>
+              </a:ext>
+            </a:extLst>
+          </p:cNvPr>
+          <p:cNvSpPr txBox="1"/>
+          <p:nvPr/>
+        </p:nvSpPr>
+        <p:spPr>
+          <a:xfrm>
+            <a:off x="7472528" y="3350255"/>
+            <a:ext cx="1725002" cy="523220"/>
+          </a:xfrm>
+          <a:prstGeom prst="rect">
+            <a:avLst/>
+          </a:prstGeom>
+          <a:noFill/>
+        </p:spPr>
+        <p:txBody>
+          <a:bodyPr wrap="square" rtlCol="0">
+            <a:spAutoFit/>
+          </a:bodyPr>
+          <a:lstStyle/>
+          <a:p>
+            <a:r>
+              <a:rPr lang="en-SG" sz="1400" dirty="0"/>
+              <a:t>getUnfilteredPersonList()</a:t>
+            </a:r>
+          </a:p>
+        </p:txBody>
+      </p:sp>
+      <p:sp>
+        <p:nvSpPr>
+          <p:cNvPr id="38" name="Multiplication Sign 37">
+            <a:extLst>
+              <a:ext uri="{FF2B5EF4-FFF2-40B4-BE49-F238E27FC236}">
+                <a16:creationId xmlns:a16="http://schemas.microsoft.com/office/drawing/2014/main" id="{03A88172-9A26-2840-C636-507E57FB47FD}"/>
+              </a:ext>
+            </a:extLst>
+          </p:cNvPr>
+          <p:cNvSpPr/>
+          <p:nvPr/>
+        </p:nvSpPr>
+        <p:spPr>
+          <a:xfrm>
+            <a:off x="6866342" y="6252508"/>
+            <a:ext cx="500281" cy="541975"/>
+          </a:xfrm>
+          <a:prstGeom prst="mathMultiply">
+            <a:avLst>
+              <a:gd name="adj1" fmla="val 10827"/>
+            </a:avLst>
+          </a:prstGeom>
+          <a:solidFill>
+            <a:srgbClr val="FF0000"/>
+          </a:solidFill>
+          <a:ln>
+            <a:noFill/>
+          </a:ln>
+        </p:spPr>
+        <p:style>
+          <a:lnRef idx="2">
+            <a:schemeClr val="accent1">
+              <a:shade val="15000"/>
+            </a:schemeClr>
+          </a:lnRef>
+          <a:fillRef idx="1">
+            <a:schemeClr val="accent1"/>
+          </a:fillRef>
+          <a:effectRef idx="0">
+            <a:schemeClr val="accent1"/>
+          </a:effectRef>
+          <a:fontRef idx="minor">
+            <a:schemeClr val="lt1"/>
+          </a:fontRef>
+        </p:style>
+        <p:txBody>
+          <a:bodyPr rtlCol="0" anchor="ctr"/>
+          <a:lstStyle/>
+          <a:p>
+            <a:pPr algn="ctr"/>
+            <a:endParaRPr lang="en-SG"/>
+          </a:p>
+        </p:txBody>
+      </p:sp>
+      <p:sp>
+        <p:nvSpPr>
+          <p:cNvPr id="39" name="TextBox 38">
+            <a:extLst>
+              <a:ext uri="{FF2B5EF4-FFF2-40B4-BE49-F238E27FC236}">
+                <a16:creationId xmlns:a16="http://schemas.microsoft.com/office/drawing/2014/main" id="{48219630-618D-39EB-ED44-A2200ACE44BA}"/>
+              </a:ext>
+            </a:extLst>
+          </p:cNvPr>
+          <p:cNvSpPr txBox="1"/>
+          <p:nvPr/>
+        </p:nvSpPr>
+        <p:spPr>
+          <a:xfrm>
+            <a:off x="8267703" y="4163657"/>
+            <a:ext cx="2294745" cy="307777"/>
+          </a:xfrm>
+          <a:prstGeom prst="rect">
+            <a:avLst/>
+          </a:prstGeom>
+          <a:noFill/>
+        </p:spPr>
+        <p:txBody>
+          <a:bodyPr wrap="square" rtlCol="0">
+            <a:spAutoFit/>
+          </a:bodyPr>
+          <a:lstStyle/>
+          <a:p>
+            <a:r>
+              <a:rPr lang="en-SG" sz="1400" dirty="0"/>
+              <a:t>persons</a:t>
+            </a:r>
+          </a:p>
+        </p:txBody>
+      </p:sp>
+      <p:sp>
+        <p:nvSpPr>
+          <p:cNvPr id="47" name="Rectangle 46">
+            <a:extLst>
+              <a:ext uri="{FF2B5EF4-FFF2-40B4-BE49-F238E27FC236}">
+                <a16:creationId xmlns:a16="http://schemas.microsoft.com/office/drawing/2014/main" id="{47FAC9E0-3B8D-3577-52E3-13D46B6FF6C3}"/>
+              </a:ext>
+            </a:extLst>
+          </p:cNvPr>
+          <p:cNvSpPr/>
+          <p:nvPr/>
+        </p:nvSpPr>
+        <p:spPr>
+          <a:xfrm>
+            <a:off x="7116483" y="4852077"/>
+            <a:ext cx="214820" cy="427119"/>
+          </a:xfrm>
+          <a:prstGeom prst="rect">
+            <a:avLst/>
+          </a:prstGeom>
+          <a:solidFill>
+            <a:schemeClr val="bg1"/>
+          </a:solidFill>
+        </p:spPr>
+        <p:style>
+          <a:lnRef idx="2">
+            <a:schemeClr val="accent1">
+              <a:shade val="15000"/>
+            </a:schemeClr>
+          </a:lnRef>
+          <a:fillRef idx="1">
+            <a:schemeClr val="accent1"/>
+          </a:fillRef>
+          <a:effectRef idx="0">
+            <a:schemeClr val="accent1"/>
+          </a:effectRef>
+          <a:fontRef idx="minor">
+            <a:schemeClr val="lt1"/>
+          </a:fontRef>
+        </p:style>
+        <p:txBody>
+          <a:bodyPr rtlCol="0" anchor="ctr"/>
+          <a:lstStyle/>
+          <a:p>
+            <a:pPr algn="ctr"/>
+            <a:endParaRPr lang="en-SG"/>
+          </a:p>
+        </p:txBody>
+      </p:sp>
+      <p:cxnSp>
+        <p:nvCxnSpPr>
+          <p:cNvPr id="49" name="Connector: Elbow 48">
+            <a:extLst>
+              <a:ext uri="{FF2B5EF4-FFF2-40B4-BE49-F238E27FC236}">
+                <a16:creationId xmlns:a16="http://schemas.microsoft.com/office/drawing/2014/main" id="{7F3E4E2E-2579-8A0F-1F80-075C3D947816}"/>
+              </a:ext>
+            </a:extLst>
+          </p:cNvPr>
+          <p:cNvCxnSpPr>
+            <a:cxnSpLocks/>
+            <a:endCxn id="47" idx="3"/>
+          </p:cNvCxnSpPr>
+          <p:nvPr/>
+        </p:nvCxnSpPr>
+        <p:spPr>
+          <a:xfrm rot="16200000" flipH="1">
+            <a:off x="7029033" y="4763367"/>
+            <a:ext cx="462876" cy="141664"/>
+          </a:xfrm>
+          <a:prstGeom prst="bentConnector4">
+            <a:avLst>
+              <a:gd name="adj1" fmla="val 26931"/>
+              <a:gd name="adj2" fmla="val 261368"/>
+            </a:avLst>
+          </a:prstGeom>
+          <a:ln w="19050" cap="flat" cmpd="sng" algn="ctr">
+            <a:solidFill>
+              <a:schemeClr val="dk1"/>
+            </a:solidFill>
+            <a:prstDash val="solid"/>
+            <a:round/>
+            <a:headEnd type="none" w="med" len="med"/>
+            <a:tailEnd type="arrow" w="med" len="med"/>
+          </a:ln>
+        </p:spPr>
+        <p:style>
+          <a:lnRef idx="0">
+            <a:scrgbClr r="0" g="0" b="0"/>
+          </a:lnRef>
+          <a:fillRef idx="0">
+            <a:scrgbClr r="0" g="0" b="0"/>
+          </a:fillRef>
+          <a:effectRef idx="0">
+            <a:scrgbClr r="0" g="0" b="0"/>
+          </a:effectRef>
+          <a:fontRef idx="minor">
+            <a:schemeClr val="tx1"/>
+          </a:fontRef>
+        </p:style>
+      </p:cxnSp>
+      <p:sp>
+        <p:nvSpPr>
+          <p:cNvPr id="53" name="TextBox 52">
+            <a:extLst>
+              <a:ext uri="{FF2B5EF4-FFF2-40B4-BE49-F238E27FC236}">
+                <a16:creationId xmlns:a16="http://schemas.microsoft.com/office/drawing/2014/main" id="{EB16631E-0E20-1984-0A34-A9DFA8824E05}"/>
+              </a:ext>
+            </a:extLst>
+          </p:cNvPr>
+          <p:cNvSpPr txBox="1"/>
+          <p:nvPr/>
+        </p:nvSpPr>
+        <p:spPr>
+          <a:xfrm>
+            <a:off x="7562792" y="4542417"/>
+            <a:ext cx="1617395" cy="523220"/>
+          </a:xfrm>
+          <a:prstGeom prst="rect">
+            <a:avLst/>
+          </a:prstGeom>
+          <a:noFill/>
+        </p:spPr>
+        <p:txBody>
+          <a:bodyPr wrap="square" rtlCol="0">
+            <a:spAutoFit/>
+          </a:bodyPr>
+          <a:lstStyle/>
+          <a:p>
+            <a:r>
+              <a:rPr lang="en-SG" sz="1400" dirty="0"/>
+              <a:t>countPersonsPerCategory(persons)</a:t>
+            </a:r>
+          </a:p>
+        </p:txBody>
+      </p:sp>
+      <p:cxnSp>
+        <p:nvCxnSpPr>
+          <p:cNvPr id="92" name="Straight Connector 91">
+            <a:extLst>
+              <a:ext uri="{FF2B5EF4-FFF2-40B4-BE49-F238E27FC236}">
+                <a16:creationId xmlns:a16="http://schemas.microsoft.com/office/drawing/2014/main" id="{BCDB4737-64CF-00EF-C2C0-89B372755D25}"/>
+              </a:ext>
+            </a:extLst>
+          </p:cNvPr>
+          <p:cNvCxnSpPr/>
+          <p:nvPr/>
+        </p:nvCxnSpPr>
+        <p:spPr>
+          <a:xfrm>
+            <a:off x="7331303" y="5186053"/>
+            <a:ext cx="235956" cy="0"/>
+          </a:xfrm>
+          <a:prstGeom prst="line">
+            <a:avLst/>
+          </a:prstGeom>
+          <a:ln>
+            <a:solidFill>
+              <a:schemeClr val="tx1"/>
+            </a:solidFill>
+            <a:prstDash val="dash"/>
+          </a:ln>
+        </p:spPr>
+        <p:style>
+          <a:lnRef idx="2">
+            <a:schemeClr val="accent1"/>
+          </a:lnRef>
+          <a:fillRef idx="0">
+            <a:schemeClr val="accent1"/>
+          </a:fillRef>
+          <a:effectRef idx="1">
+            <a:schemeClr val="accent1"/>
+          </a:effectRef>
+          <a:fontRef idx="minor">
+            <a:schemeClr val="tx1"/>
+          </a:fontRef>
+        </p:style>
+      </p:cxnSp>
+      <p:cxnSp>
+        <p:nvCxnSpPr>
+          <p:cNvPr id="93" name="Straight Connector 92">
+            <a:extLst>
+              <a:ext uri="{FF2B5EF4-FFF2-40B4-BE49-F238E27FC236}">
+                <a16:creationId xmlns:a16="http://schemas.microsoft.com/office/drawing/2014/main" id="{24783C68-1874-6C9D-19E7-70A22E43C285}"/>
+              </a:ext>
+            </a:extLst>
+          </p:cNvPr>
+          <p:cNvCxnSpPr>
+            <a:cxnSpLocks/>
+          </p:cNvCxnSpPr>
+          <p:nvPr/>
+        </p:nvCxnSpPr>
+        <p:spPr>
+          <a:xfrm flipV="1">
+            <a:off x="7565799" y="5173111"/>
+            <a:ext cx="4466" cy="325315"/>
+          </a:xfrm>
+          <a:prstGeom prst="line">
+            <a:avLst/>
+          </a:prstGeom>
+          <a:ln>
+            <a:solidFill>
+              <a:schemeClr val="tx1"/>
+            </a:solidFill>
+            <a:prstDash val="dash"/>
+          </a:ln>
+        </p:spPr>
+        <p:style>
+          <a:lnRef idx="2">
+            <a:schemeClr val="accent1"/>
+          </a:lnRef>
+          <a:fillRef idx="0">
+            <a:schemeClr val="accent1"/>
+          </a:fillRef>
+          <a:effectRef idx="1">
+            <a:schemeClr val="accent1"/>
+          </a:effectRef>
+          <a:fontRef idx="minor">
+            <a:schemeClr val="tx1"/>
+          </a:fontRef>
+        </p:style>
+      </p:cxnSp>
+      <p:cxnSp>
+        <p:nvCxnSpPr>
+          <p:cNvPr id="97" name="Straight Connector 96">
+            <a:extLst>
+              <a:ext uri="{FF2B5EF4-FFF2-40B4-BE49-F238E27FC236}">
+                <a16:creationId xmlns:a16="http://schemas.microsoft.com/office/drawing/2014/main" id="{E0DF5544-494D-CAD5-229C-AD8E74E1FBC0}"/>
+              </a:ext>
+            </a:extLst>
+          </p:cNvPr>
+          <p:cNvCxnSpPr>
+            <a:cxnSpLocks/>
+          </p:cNvCxnSpPr>
+          <p:nvPr/>
+        </p:nvCxnSpPr>
+        <p:spPr>
+          <a:xfrm flipH="1" flipV="1">
+            <a:off x="7223359" y="5493599"/>
+            <a:ext cx="353386" cy="4827"/>
+          </a:xfrm>
+          <a:prstGeom prst="line">
+            <a:avLst/>
+          </a:prstGeom>
+          <a:ln w="19050" cap="flat" cmpd="sng" algn="ctr">
+            <a:solidFill>
+              <a:schemeClr val="tx1"/>
+            </a:solidFill>
+            <a:prstDash val="dash"/>
+            <a:round/>
+            <a:headEnd type="none" w="med" len="med"/>
+            <a:tailEnd type="arrow" w="med" len="med"/>
+          </a:ln>
+        </p:spPr>
+        <p:style>
+          <a:lnRef idx="0">
+            <a:scrgbClr r="0" g="0" b="0"/>
+          </a:lnRef>
+          <a:fillRef idx="0">
+            <a:scrgbClr r="0" g="0" b="0"/>
+          </a:fillRef>
+          <a:effectRef idx="0">
+            <a:scrgbClr r="0" g="0" b="0"/>
+          </a:effectRef>
+          <a:fontRef idx="minor">
+            <a:schemeClr val="tx1"/>
+          </a:fontRef>
+        </p:style>
+      </p:cxnSp>
+      <p:sp>
+        <p:nvSpPr>
+          <p:cNvPr id="102" name="TextBox 101">
+            <a:extLst>
+              <a:ext uri="{FF2B5EF4-FFF2-40B4-BE49-F238E27FC236}">
+                <a16:creationId xmlns:a16="http://schemas.microsoft.com/office/drawing/2014/main" id="{FC3415C6-BE2D-63A5-EFE5-F902188EE8A0}"/>
+              </a:ext>
+            </a:extLst>
+          </p:cNvPr>
+          <p:cNvSpPr txBox="1"/>
+          <p:nvPr/>
+        </p:nvSpPr>
+        <p:spPr>
+          <a:xfrm>
+            <a:off x="7562791" y="5182786"/>
+            <a:ext cx="1617395" cy="523220"/>
+          </a:xfrm>
+          <a:prstGeom prst="rect">
+            <a:avLst/>
+          </a:prstGeom>
+          <a:noFill/>
+        </p:spPr>
+        <p:txBody>
+          <a:bodyPr wrap="square" rtlCol="0">
+            <a:spAutoFit/>
+          </a:bodyPr>
+          <a:lstStyle/>
+          <a:p>
+            <a:r>
+              <a:rPr lang="en-SG" sz="1400" dirty="0"/>
+              <a:t>category count map</a:t>
+            </a:r>
+          </a:p>
+        </p:txBody>
+      </p:sp>
+    </p:spTree>
+    <p:extLst>
+      <p:ext uri="{BB962C8B-B14F-4D97-AF65-F5344CB8AC3E}">
+        <p14:creationId xmlns:p14="http://schemas.microsoft.com/office/powerpoint/2010/main" val="3239888040"/>
+      </p:ext>
+    </p:extLst>
+  </p:cSld>
+  <p:clrMapOvr>
+    <a:masterClrMapping/>
+  </p:clrMapOvr>
+</p:sld>
+</file>
+
+<file path=ppt/slides/slide4.xml><?xml version="1.0" encoding="utf-8"?>
+<p:sld xmlns:a="http://schemas.openxmlformats.org/drawingml/2006/main" xmlns:r="http://schemas.openxmlformats.org/officeDocument/2006/relationships" xmlns:p="http://schemas.openxmlformats.org/presentationml/2006/main">
+  <p:cSld>
+    <p:spTree>
+      <p:nvGrpSpPr>
+        <p:cNvPr id="1" name=""/>
+        <p:cNvGrpSpPr/>
+        <p:nvPr/>
+      </p:nvGrpSpPr>
+      <p:grpSpPr>
+        <a:xfrm>
+          <a:off x="0" y="0"/>
+          <a:ext cx="0" cy="0"/>
+          <a:chOff x="0" y="0"/>
+          <a:chExt cx="0" cy="0"/>
+        </a:xfrm>
+      </p:grpSpPr>
+      <p:sp>
+        <p:nvSpPr>
+          <p:cNvPr id="4" name="Rectangle 3">
+            <a:extLst>
+              <a:ext uri="{FF2B5EF4-FFF2-40B4-BE49-F238E27FC236}">
+                <a16:creationId xmlns:a16="http://schemas.microsoft.com/office/drawing/2014/main" id="{343048FD-068A-F78A-7C83-210A342171A5}"/>
+              </a:ext>
+            </a:extLst>
+          </p:cNvPr>
+          <p:cNvSpPr/>
+          <p:nvPr/>
+        </p:nvSpPr>
+        <p:spPr>
+          <a:xfrm>
+            <a:off x="1472766" y="1553029"/>
+            <a:ext cx="3883232" cy="4016498"/>
+          </a:xfrm>
+          <a:prstGeom prst="rect">
+            <a:avLst/>
+          </a:prstGeom>
+          <a:solidFill>
+            <a:srgbClr val="FF6699"/>
+          </a:solidFill>
+        </p:spPr>
+        <p:style>
+          <a:lnRef idx="2">
+            <a:schemeClr val="accent1">
+              <a:shade val="15000"/>
+            </a:schemeClr>
+          </a:lnRef>
+          <a:fillRef idx="1">
+            <a:schemeClr val="accent1"/>
+          </a:fillRef>
+          <a:effectRef idx="0">
+            <a:schemeClr val="accent1"/>
+          </a:effectRef>
+          <a:fontRef idx="minor">
+            <a:schemeClr val="lt1"/>
+          </a:fontRef>
+        </p:style>
+        <p:txBody>
+          <a:bodyPr rtlCol="0" anchor="ctr"/>
+          <a:lstStyle/>
+          <a:p>
+            <a:pPr algn="ctr"/>
+            <a:endParaRPr lang="en-SG" dirty="0"/>
+          </a:p>
+        </p:txBody>
+      </p:sp>
+      <p:cxnSp>
+        <p:nvCxnSpPr>
+          <p:cNvPr id="5" name="Straight Connector 4">
+            <a:extLst>
+              <a:ext uri="{FF2B5EF4-FFF2-40B4-BE49-F238E27FC236}">
+                <a16:creationId xmlns:a16="http://schemas.microsoft.com/office/drawing/2014/main" id="{9D0A26F5-6244-F521-D2B0-F6CBB4C53A89}"/>
+              </a:ext>
+            </a:extLst>
+          </p:cNvPr>
+          <p:cNvCxnSpPr>
+            <a:cxnSpLocks/>
+          </p:cNvCxnSpPr>
+          <p:nvPr/>
+        </p:nvCxnSpPr>
+        <p:spPr>
+          <a:xfrm>
+            <a:off x="2290070" y="2454358"/>
+            <a:ext cx="0" cy="3922692"/>
+          </a:xfrm>
+          <a:prstGeom prst="line">
+            <a:avLst/>
+          </a:prstGeom>
+          <a:ln w="19050" cap="flat" cmpd="sng" algn="ctr">
+            <a:solidFill>
+              <a:schemeClr val="dk1"/>
+            </a:solidFill>
+            <a:prstDash val="dash"/>
+            <a:round/>
+            <a:headEnd type="none" w="med" len="med"/>
+            <a:tailEnd type="none" w="med" len="med"/>
+          </a:ln>
+        </p:spPr>
+        <p:style>
+          <a:lnRef idx="0">
+            <a:scrgbClr r="0" g="0" b="0"/>
+          </a:lnRef>
+          <a:fillRef idx="0">
+            <a:scrgbClr r="0" g="0" b="0"/>
+          </a:fillRef>
+          <a:effectRef idx="0">
+            <a:scrgbClr r="0" g="0" b="0"/>
+          </a:effectRef>
+          <a:fontRef idx="minor">
+            <a:schemeClr val="tx1"/>
+          </a:fontRef>
+        </p:style>
+      </p:cxnSp>
+      <p:sp>
+        <p:nvSpPr>
+          <p:cNvPr id="6" name="TextBox 5">
+            <a:extLst>
+              <a:ext uri="{FF2B5EF4-FFF2-40B4-BE49-F238E27FC236}">
+                <a16:creationId xmlns:a16="http://schemas.microsoft.com/office/drawing/2014/main" id="{32C750CB-852D-DDFC-F13D-910A97339F55}"/>
+              </a:ext>
+            </a:extLst>
+          </p:cNvPr>
+          <p:cNvSpPr txBox="1"/>
+          <p:nvPr/>
+        </p:nvSpPr>
+        <p:spPr>
+          <a:xfrm>
+            <a:off x="3039245" y="1581521"/>
+            <a:ext cx="838691" cy="369332"/>
+          </a:xfrm>
+          <a:prstGeom prst="rect">
+            <a:avLst/>
+          </a:prstGeom>
+          <a:noFill/>
+        </p:spPr>
+        <p:txBody>
+          <a:bodyPr wrap="square" rtlCol="0">
+            <a:spAutoFit/>
+          </a:bodyPr>
+          <a:lstStyle/>
+          <a:p>
+            <a:r>
+              <a:rPr lang="en-SG" b="1" dirty="0">
+                <a:solidFill>
+                  <a:schemeClr val="bg1"/>
+                </a:solidFill>
+              </a:rPr>
+              <a:t>Model</a:t>
+            </a:r>
+          </a:p>
+        </p:txBody>
+      </p:sp>
+      <p:sp>
+        <p:nvSpPr>
+          <p:cNvPr id="7" name="Rectangle: Rounded Corners 6">
+            <a:extLst>
+              <a:ext uri="{FF2B5EF4-FFF2-40B4-BE49-F238E27FC236}">
+                <a16:creationId xmlns:a16="http://schemas.microsoft.com/office/drawing/2014/main" id="{AD4AA610-A547-45DF-B7AE-E45D50BA2997}"/>
+              </a:ext>
+            </a:extLst>
+          </p:cNvPr>
+          <p:cNvSpPr/>
+          <p:nvPr/>
+        </p:nvSpPr>
+        <p:spPr>
+          <a:xfrm>
+            <a:off x="1817716" y="2158304"/>
+            <a:ext cx="930435" cy="457200"/>
+          </a:xfrm>
+          <a:prstGeom prst="roundRect">
+            <a:avLst>
+              <a:gd name="adj" fmla="val 19265"/>
+            </a:avLst>
+          </a:prstGeom>
+          <a:solidFill>
+            <a:srgbClr val="C00000"/>
+          </a:solidFill>
+        </p:spPr>
+        <p:style>
+          <a:lnRef idx="2">
+            <a:schemeClr val="accent1">
+              <a:shade val="15000"/>
+            </a:schemeClr>
+          </a:lnRef>
+          <a:fillRef idx="1">
+            <a:schemeClr val="accent1"/>
+          </a:fillRef>
+          <a:effectRef idx="0">
+            <a:schemeClr val="accent1"/>
+          </a:effectRef>
+          <a:fontRef idx="minor">
+            <a:schemeClr val="lt1"/>
+          </a:fontRef>
+        </p:style>
+        <p:txBody>
+          <a:bodyPr rtlCol="0" anchor="ctr"/>
+          <a:lstStyle/>
+          <a:p>
+            <a:pPr algn="ctr"/>
+            <a:r>
+              <a:rPr lang="en-SG" dirty="0"/>
+              <a:t>:Model</a:t>
+            </a:r>
+          </a:p>
+        </p:txBody>
+      </p:sp>
+      <p:sp>
+        <p:nvSpPr>
+          <p:cNvPr id="8" name="Rectangle: Rounded Corners 7">
+            <a:extLst>
+              <a:ext uri="{FF2B5EF4-FFF2-40B4-BE49-F238E27FC236}">
+                <a16:creationId xmlns:a16="http://schemas.microsoft.com/office/drawing/2014/main" id="{B44307DA-3379-5E2F-B652-3E12FDFBE983}"/>
+              </a:ext>
+            </a:extLst>
+          </p:cNvPr>
+          <p:cNvSpPr/>
+          <p:nvPr/>
+        </p:nvSpPr>
+        <p:spPr>
+          <a:xfrm>
+            <a:off x="3429978" y="2137062"/>
+            <a:ext cx="1721922" cy="457200"/>
+          </a:xfrm>
+          <a:prstGeom prst="roundRect">
+            <a:avLst>
+              <a:gd name="adj" fmla="val 19265"/>
+            </a:avLst>
+          </a:prstGeom>
+          <a:solidFill>
+            <a:srgbClr val="C00000"/>
+          </a:solidFill>
+        </p:spPr>
+        <p:style>
+          <a:lnRef idx="2">
+            <a:schemeClr val="accent1">
+              <a:shade val="15000"/>
+            </a:schemeClr>
+          </a:lnRef>
+          <a:fillRef idx="1">
+            <a:schemeClr val="accent1"/>
+          </a:fillRef>
+          <a:effectRef idx="0">
+            <a:schemeClr val="accent1"/>
+          </a:effectRef>
+          <a:fontRef idx="minor">
+            <a:schemeClr val="lt1"/>
+          </a:fontRef>
+        </p:style>
+        <p:txBody>
+          <a:bodyPr rtlCol="0" anchor="ctr"/>
+          <a:lstStyle/>
+          <a:p>
+            <a:pPr algn="ctr"/>
+            <a:r>
+              <a:rPr lang="en-SG" dirty="0"/>
+              <a:t>:AddressBook</a:t>
+            </a:r>
+          </a:p>
+        </p:txBody>
+      </p:sp>
+      <p:cxnSp>
+        <p:nvCxnSpPr>
+          <p:cNvPr id="9" name="Straight Arrow Connector 8">
+            <a:extLst>
+              <a:ext uri="{FF2B5EF4-FFF2-40B4-BE49-F238E27FC236}">
+                <a16:creationId xmlns:a16="http://schemas.microsoft.com/office/drawing/2014/main" id="{A9762A8E-426A-7E3B-BBEB-9B6AC13AAB96}"/>
+              </a:ext>
+            </a:extLst>
+          </p:cNvPr>
+          <p:cNvCxnSpPr>
+            <a:cxnSpLocks/>
+          </p:cNvCxnSpPr>
+          <p:nvPr/>
+        </p:nvCxnSpPr>
+        <p:spPr>
+          <a:xfrm>
+            <a:off x="0" y="3254874"/>
+            <a:ext cx="2189062" cy="0"/>
+          </a:xfrm>
+          <a:prstGeom prst="straightConnector1">
+            <a:avLst/>
+          </a:prstGeom>
+          <a:ln w="19050" cap="flat" cmpd="sng" algn="ctr">
+            <a:solidFill>
+              <a:schemeClr val="dk1"/>
+            </a:solidFill>
+            <a:prstDash val="solid"/>
+            <a:round/>
+            <a:headEnd type="none" w="med" len="med"/>
+            <a:tailEnd type="arrow" w="med" len="med"/>
+          </a:ln>
+        </p:spPr>
+        <p:style>
+          <a:lnRef idx="0">
+            <a:scrgbClr r="0" g="0" b="0"/>
+          </a:lnRef>
+          <a:fillRef idx="0">
+            <a:scrgbClr r="0" g="0" b="0"/>
+          </a:fillRef>
+          <a:effectRef idx="0">
+            <a:scrgbClr r="0" g="0" b="0"/>
+          </a:effectRef>
+          <a:fontRef idx="minor">
+            <a:schemeClr val="tx1"/>
+          </a:fontRef>
+        </p:style>
+      </p:cxnSp>
+      <p:sp>
+        <p:nvSpPr>
+          <p:cNvPr id="10" name="Rectangle 9">
+            <a:extLst>
+              <a:ext uri="{FF2B5EF4-FFF2-40B4-BE49-F238E27FC236}">
+                <a16:creationId xmlns:a16="http://schemas.microsoft.com/office/drawing/2014/main" id="{F253BC3D-68D0-CB14-980F-D88BE8A71796}"/>
+              </a:ext>
+            </a:extLst>
+          </p:cNvPr>
+          <p:cNvSpPr/>
+          <p:nvPr/>
+        </p:nvSpPr>
+        <p:spPr>
+          <a:xfrm>
+            <a:off x="2189063" y="3242792"/>
+            <a:ext cx="186228" cy="1970475"/>
+          </a:xfrm>
+          <a:prstGeom prst="rect">
+            <a:avLst/>
+          </a:prstGeom>
+          <a:solidFill>
+            <a:schemeClr val="bg1"/>
+          </a:solidFill>
+        </p:spPr>
+        <p:style>
+          <a:lnRef idx="2">
+            <a:schemeClr val="accent1">
+              <a:shade val="15000"/>
+            </a:schemeClr>
+          </a:lnRef>
+          <a:fillRef idx="1">
+            <a:schemeClr val="accent1"/>
+          </a:fillRef>
+          <a:effectRef idx="0">
+            <a:schemeClr val="accent1"/>
+          </a:effectRef>
+          <a:fontRef idx="minor">
+            <a:schemeClr val="lt1"/>
+          </a:fontRef>
+        </p:style>
+        <p:txBody>
+          <a:bodyPr rtlCol="0" anchor="ctr"/>
+          <a:lstStyle/>
+          <a:p>
+            <a:pPr algn="ctr"/>
+            <a:endParaRPr lang="en-SG"/>
+          </a:p>
+        </p:txBody>
+      </p:sp>
+      <p:cxnSp>
+        <p:nvCxnSpPr>
+          <p:cNvPr id="11" name="Straight Arrow Connector 10">
+            <a:extLst>
+              <a:ext uri="{FF2B5EF4-FFF2-40B4-BE49-F238E27FC236}">
+                <a16:creationId xmlns:a16="http://schemas.microsoft.com/office/drawing/2014/main" id="{B0EA210E-A068-24FB-EB1C-A2E5C7384E72}"/>
+              </a:ext>
+            </a:extLst>
+          </p:cNvPr>
+          <p:cNvCxnSpPr>
+            <a:cxnSpLocks/>
+          </p:cNvCxnSpPr>
+          <p:nvPr/>
+        </p:nvCxnSpPr>
+        <p:spPr>
+          <a:xfrm flipH="1">
+            <a:off x="0" y="5213267"/>
+            <a:ext cx="2182136" cy="0"/>
+          </a:xfrm>
+          <a:prstGeom prst="straightConnector1">
+            <a:avLst/>
+          </a:prstGeom>
+          <a:ln w="19050" cap="flat" cmpd="sng" algn="ctr">
+            <a:solidFill>
+              <a:schemeClr val="dk1"/>
+            </a:solidFill>
+            <a:prstDash val="dash"/>
+            <a:round/>
+            <a:headEnd type="none" w="med" len="med"/>
+            <a:tailEnd type="arrow" w="med" len="med"/>
+          </a:ln>
+        </p:spPr>
+        <p:style>
+          <a:lnRef idx="0">
+            <a:scrgbClr r="0" g="0" b="0"/>
+          </a:lnRef>
+          <a:fillRef idx="0">
+            <a:scrgbClr r="0" g="0" b="0"/>
+          </a:fillRef>
+          <a:effectRef idx="0">
+            <a:scrgbClr r="0" g="0" b="0"/>
+          </a:effectRef>
+          <a:fontRef idx="minor">
+            <a:schemeClr val="tx1"/>
+          </a:fontRef>
+        </p:style>
+      </p:cxnSp>
+      <p:sp>
+        <p:nvSpPr>
+          <p:cNvPr id="12" name="TextBox 11">
+            <a:extLst>
+              <a:ext uri="{FF2B5EF4-FFF2-40B4-BE49-F238E27FC236}">
+                <a16:creationId xmlns:a16="http://schemas.microsoft.com/office/drawing/2014/main" id="{6EA8EDE0-2DE2-D8D8-2D8B-F80D26990FC3}"/>
+              </a:ext>
+            </a:extLst>
+          </p:cNvPr>
+          <p:cNvSpPr txBox="1"/>
+          <p:nvPr/>
+        </p:nvSpPr>
+        <p:spPr>
+          <a:xfrm>
+            <a:off x="229726" y="2673579"/>
+            <a:ext cx="1205343" cy="523220"/>
+          </a:xfrm>
+          <a:prstGeom prst="rect">
+            <a:avLst/>
+          </a:prstGeom>
+          <a:noFill/>
+        </p:spPr>
+        <p:txBody>
+          <a:bodyPr wrap="square" rtlCol="0">
+            <a:spAutoFit/>
+          </a:bodyPr>
+          <a:lstStyle/>
+          <a:p>
+            <a:r>
+              <a:rPr lang="en-SG" sz="1400" dirty="0"/>
+              <a:t>getUnfilteredPersonList()</a:t>
+            </a:r>
+          </a:p>
+        </p:txBody>
+      </p:sp>
+      <p:cxnSp>
+        <p:nvCxnSpPr>
+          <p:cNvPr id="13" name="Straight Connector 12">
+            <a:extLst>
+              <a:ext uri="{FF2B5EF4-FFF2-40B4-BE49-F238E27FC236}">
+                <a16:creationId xmlns:a16="http://schemas.microsoft.com/office/drawing/2014/main" id="{D14BED4E-A368-F735-C51B-E8D5EDDC847C}"/>
+              </a:ext>
+            </a:extLst>
+          </p:cNvPr>
+          <p:cNvCxnSpPr>
+            <a:cxnSpLocks/>
+          </p:cNvCxnSpPr>
+          <p:nvPr/>
+        </p:nvCxnSpPr>
+        <p:spPr>
+          <a:xfrm>
+            <a:off x="4271270" y="2615504"/>
+            <a:ext cx="0" cy="3761546"/>
+          </a:xfrm>
+          <a:prstGeom prst="line">
+            <a:avLst/>
+          </a:prstGeom>
+          <a:ln w="19050" cap="flat" cmpd="sng" algn="ctr">
+            <a:solidFill>
+              <a:schemeClr val="dk1"/>
+            </a:solidFill>
+            <a:prstDash val="dash"/>
+            <a:round/>
+            <a:headEnd type="none" w="med" len="med"/>
+            <a:tailEnd type="none" w="med" len="med"/>
+          </a:ln>
+        </p:spPr>
+        <p:style>
+          <a:lnRef idx="0">
+            <a:scrgbClr r="0" g="0" b="0"/>
+          </a:lnRef>
+          <a:fillRef idx="0">
+            <a:scrgbClr r="0" g="0" b="0"/>
+          </a:fillRef>
+          <a:effectRef idx="0">
+            <a:scrgbClr r="0" g="0" b="0"/>
+          </a:effectRef>
+          <a:fontRef idx="minor">
+            <a:schemeClr val="tx1"/>
+          </a:fontRef>
+        </p:style>
+      </p:cxnSp>
+      <p:sp>
+        <p:nvSpPr>
+          <p:cNvPr id="14" name="Rectangle 13">
+            <a:extLst>
+              <a:ext uri="{FF2B5EF4-FFF2-40B4-BE49-F238E27FC236}">
+                <a16:creationId xmlns:a16="http://schemas.microsoft.com/office/drawing/2014/main" id="{F7C9B59A-ED2D-C968-4303-57A2EDAB3A30}"/>
+              </a:ext>
+            </a:extLst>
+          </p:cNvPr>
+          <p:cNvSpPr/>
+          <p:nvPr/>
+        </p:nvSpPr>
+        <p:spPr>
+          <a:xfrm>
+            <a:off x="4197825" y="3657601"/>
+            <a:ext cx="186228" cy="1235033"/>
+          </a:xfrm>
+          <a:prstGeom prst="rect">
+            <a:avLst/>
+          </a:prstGeom>
+          <a:solidFill>
+            <a:schemeClr val="bg1"/>
+          </a:solidFill>
+        </p:spPr>
+        <p:style>
+          <a:lnRef idx="2">
+            <a:schemeClr val="accent1">
+              <a:shade val="15000"/>
+            </a:schemeClr>
+          </a:lnRef>
+          <a:fillRef idx="1">
+            <a:schemeClr val="accent1"/>
+          </a:fillRef>
+          <a:effectRef idx="0">
+            <a:schemeClr val="accent1"/>
+          </a:effectRef>
+          <a:fontRef idx="minor">
+            <a:schemeClr val="lt1"/>
+          </a:fontRef>
+        </p:style>
+        <p:txBody>
+          <a:bodyPr rtlCol="0" anchor="ctr"/>
+          <a:lstStyle/>
+          <a:p>
+            <a:pPr algn="ctr"/>
+            <a:endParaRPr lang="en-SG"/>
+          </a:p>
+        </p:txBody>
+      </p:sp>
+      <p:cxnSp>
+        <p:nvCxnSpPr>
+          <p:cNvPr id="15" name="Straight Arrow Connector 14">
+            <a:extLst>
+              <a:ext uri="{FF2B5EF4-FFF2-40B4-BE49-F238E27FC236}">
+                <a16:creationId xmlns:a16="http://schemas.microsoft.com/office/drawing/2014/main" id="{72B24B15-46EC-63E0-0BB2-9FB3C115463B}"/>
+              </a:ext>
+            </a:extLst>
+          </p:cNvPr>
+          <p:cNvCxnSpPr>
+            <a:cxnSpLocks/>
+          </p:cNvCxnSpPr>
+          <p:nvPr/>
+        </p:nvCxnSpPr>
+        <p:spPr>
+          <a:xfrm>
+            <a:off x="2375291" y="3657601"/>
+            <a:ext cx="1822534" cy="0"/>
+          </a:xfrm>
+          <a:prstGeom prst="straightConnector1">
+            <a:avLst/>
+          </a:prstGeom>
+          <a:ln w="19050" cap="flat" cmpd="sng" algn="ctr">
+            <a:solidFill>
+              <a:schemeClr val="dk1"/>
+            </a:solidFill>
+            <a:prstDash val="solid"/>
+            <a:round/>
+            <a:headEnd type="none" w="med" len="med"/>
+            <a:tailEnd type="arrow" w="med" len="med"/>
+          </a:ln>
+        </p:spPr>
+        <p:style>
+          <a:lnRef idx="0">
+            <a:scrgbClr r="0" g="0" b="0"/>
+          </a:lnRef>
+          <a:fillRef idx="0">
+            <a:scrgbClr r="0" g="0" b="0"/>
+          </a:fillRef>
+          <a:effectRef idx="0">
+            <a:scrgbClr r="0" g="0" b="0"/>
+          </a:effectRef>
+          <a:fontRef idx="minor">
+            <a:schemeClr val="tx1"/>
+          </a:fontRef>
+        </p:style>
+      </p:cxnSp>
+      <p:cxnSp>
+        <p:nvCxnSpPr>
+          <p:cNvPr id="16" name="Straight Arrow Connector 15">
+            <a:extLst>
+              <a:ext uri="{FF2B5EF4-FFF2-40B4-BE49-F238E27FC236}">
+                <a16:creationId xmlns:a16="http://schemas.microsoft.com/office/drawing/2014/main" id="{2FC9E46E-DE0A-A7FF-CE4F-8D40F2BD5B09}"/>
+              </a:ext>
+            </a:extLst>
+          </p:cNvPr>
+          <p:cNvCxnSpPr>
+            <a:cxnSpLocks/>
+          </p:cNvCxnSpPr>
+          <p:nvPr/>
+        </p:nvCxnSpPr>
+        <p:spPr>
+          <a:xfrm flipH="1">
+            <a:off x="2377239" y="4892634"/>
+            <a:ext cx="1820586" cy="0"/>
+          </a:xfrm>
+          <a:prstGeom prst="straightConnector1">
+            <a:avLst/>
+          </a:prstGeom>
+          <a:ln w="19050" cap="flat" cmpd="sng" algn="ctr">
+            <a:solidFill>
+              <a:schemeClr val="dk1"/>
+            </a:solidFill>
+            <a:prstDash val="dash"/>
+            <a:round/>
+            <a:headEnd type="none" w="med" len="med"/>
+            <a:tailEnd type="arrow" w="med" len="med"/>
+          </a:ln>
+        </p:spPr>
+        <p:style>
+          <a:lnRef idx="0">
+            <a:scrgbClr r="0" g="0" b="0"/>
+          </a:lnRef>
+          <a:fillRef idx="0">
+            <a:scrgbClr r="0" g="0" b="0"/>
+          </a:fillRef>
+          <a:effectRef idx="0">
+            <a:scrgbClr r="0" g="0" b="0"/>
+          </a:effectRef>
+          <a:fontRef idx="minor">
+            <a:schemeClr val="tx1"/>
+          </a:fontRef>
+        </p:style>
+      </p:cxnSp>
+      <p:sp>
+        <p:nvSpPr>
+          <p:cNvPr id="17" name="TextBox 16">
+            <a:extLst>
+              <a:ext uri="{FF2B5EF4-FFF2-40B4-BE49-F238E27FC236}">
+                <a16:creationId xmlns:a16="http://schemas.microsoft.com/office/drawing/2014/main" id="{92E11382-C25F-9B58-A392-34E2CF0FE9D7}"/>
+              </a:ext>
+            </a:extLst>
+          </p:cNvPr>
+          <p:cNvSpPr txBox="1"/>
+          <p:nvPr/>
+        </p:nvSpPr>
+        <p:spPr>
+          <a:xfrm>
+            <a:off x="2676282" y="3254874"/>
+            <a:ext cx="1521543" cy="307777"/>
+          </a:xfrm>
+          <a:prstGeom prst="rect">
+            <a:avLst/>
+          </a:prstGeom>
+          <a:noFill/>
+        </p:spPr>
+        <p:txBody>
+          <a:bodyPr wrap="square" rtlCol="0">
+            <a:spAutoFit/>
+          </a:bodyPr>
+          <a:lstStyle/>
+          <a:p>
+            <a:r>
+              <a:rPr lang="en-SG" sz="1400" dirty="0"/>
+              <a:t>getPersonList()</a:t>
+            </a:r>
+          </a:p>
+        </p:txBody>
+      </p:sp>
+      <p:sp>
+        <p:nvSpPr>
+          <p:cNvPr id="18" name="TextBox 17">
+            <a:extLst>
+              <a:ext uri="{FF2B5EF4-FFF2-40B4-BE49-F238E27FC236}">
+                <a16:creationId xmlns:a16="http://schemas.microsoft.com/office/drawing/2014/main" id="{F64EA4BF-67C5-021C-4AB6-69FD34E36AFE}"/>
+              </a:ext>
+            </a:extLst>
+          </p:cNvPr>
+          <p:cNvSpPr txBox="1"/>
+          <p:nvPr/>
+        </p:nvSpPr>
+        <p:spPr>
+          <a:xfrm>
+            <a:off x="2769396" y="4968702"/>
+            <a:ext cx="1521543" cy="523220"/>
+          </a:xfrm>
+          <a:prstGeom prst="rect">
+            <a:avLst/>
+          </a:prstGeom>
+          <a:noFill/>
+        </p:spPr>
+        <p:txBody>
+          <a:bodyPr wrap="square" rtlCol="0">
+            <a:spAutoFit/>
+          </a:bodyPr>
+          <a:lstStyle/>
+          <a:p>
+            <a:r>
+              <a:rPr lang="en-SG" sz="1400" dirty="0"/>
+              <a:t>Unmodifiable persons list</a:t>
+            </a:r>
+          </a:p>
+        </p:txBody>
+      </p:sp>
+    </p:spTree>
+    <p:extLst>
+      <p:ext uri="{BB962C8B-B14F-4D97-AF65-F5344CB8AC3E}">
+        <p14:creationId xmlns:p14="http://schemas.microsoft.com/office/powerpoint/2010/main" val="1829632558"/>
       </p:ext>
     </p:extLst>
   </p:cSld>

</xml_diff>